<commit_message>
Improve presentation readability and layout
Co-authored-by: arena-agent <297053741+arena-agent@users.noreply.github.com>
</commit_message>
<xml_diff>
--- a/POWER POINT MANIFEST-ELYSE.pptx
+++ b/POWER POINT MANIFEST-ELYSE.pptx
@@ -4723,7 +4723,7 @@
       </p:sp>
       <p:pic>
         <p:nvPicPr>
-          <p:cNvPr id="8" name="Picture 7" descr="eng_antan-01.jpg"/>
+          <p:cNvPr id="8" name="Picture 7" descr="eng_antan-02.jpg"/>
           <p:cNvPicPr>
             <a:picLocks noChangeAspect="1"/>
           </p:cNvPicPr>
@@ -4754,8 +4754,8 @@
         </p:nvSpPr>
         <p:spPr>
           <a:xfrm>
-            <a:off x="2404872" y="1609344"/>
-            <a:ext cx="3429000" cy="310896"/>
+            <a:off x="2404872" y="1591056"/>
+            <a:ext cx="3429000" cy="347472"/>
           </a:xfrm>
           <a:prstGeom prst="rect">
             <a:avLst/>
@@ -4774,7 +4774,7 @@
               </a:lnSpc>
             </a:pPr>
             <a:r>
-              <a:rPr sz="1350" b="1" i="0">
+              <a:rPr sz="1450" b="1" i="0">
                 <a:solidFill>
                   <a:srgbClr val="102D4D"/>
                 </a:solidFill>
@@ -4793,8 +4793,8 @@
         </p:nvSpPr>
         <p:spPr>
           <a:xfrm>
-            <a:off x="2404872" y="1993392"/>
-            <a:ext cx="3429000" cy="1225296"/>
+            <a:off x="2404872" y="1984248"/>
+            <a:ext cx="3429000" cy="1252728"/>
           </a:xfrm>
           <a:prstGeom prst="rect">
             <a:avLst/>
@@ -4809,11 +4809,11 @@
           <a:p>
             <a:pPr algn="l">
               <a:lnSpc>
-                <a:spcPct val="103000"/>
+                <a:spcPct val="102000"/>
               </a:lnSpc>
             </a:pPr>
             <a:r>
-              <a:rPr sz="1019" b="0" i="0">
+              <a:rPr sz="1170" b="0" i="0">
                 <a:solidFill>
                   <a:srgbClr val="627080"/>
                 </a:solidFill>
@@ -4945,8 +4945,8 @@
         </p:nvSpPr>
         <p:spPr>
           <a:xfrm>
-            <a:off x="7964423" y="1609344"/>
-            <a:ext cx="3429000" cy="310896"/>
+            <a:off x="7964423" y="1591056"/>
+            <a:ext cx="3429000" cy="347472"/>
           </a:xfrm>
           <a:prstGeom prst="rect">
             <a:avLst/>
@@ -4965,7 +4965,7 @@
               </a:lnSpc>
             </a:pPr>
             <a:r>
-              <a:rPr sz="1350" b="1" i="0">
+              <a:rPr sz="1450" b="1" i="0">
                 <a:solidFill>
                   <a:srgbClr val="102D4D"/>
                 </a:solidFill>
@@ -4984,8 +4984,8 @@
         </p:nvSpPr>
         <p:spPr>
           <a:xfrm>
-            <a:off x="7964423" y="1993392"/>
-            <a:ext cx="3429000" cy="1225296"/>
+            <a:off x="7964423" y="1984248"/>
+            <a:ext cx="3429000" cy="1252728"/>
           </a:xfrm>
           <a:prstGeom prst="rect">
             <a:avLst/>
@@ -5000,11 +5000,11 @@
           <a:p>
             <a:pPr algn="l">
               <a:lnSpc>
-                <a:spcPct val="103000"/>
+                <a:spcPct val="102000"/>
               </a:lnSpc>
             </a:pPr>
             <a:r>
-              <a:rPr sz="1019" b="0" i="0">
+              <a:rPr sz="1170" b="0" i="0">
                 <a:solidFill>
                   <a:srgbClr val="627080"/>
                 </a:solidFill>
@@ -5136,8 +5136,8 @@
         </p:nvSpPr>
         <p:spPr>
           <a:xfrm>
-            <a:off x="2404872" y="3749039"/>
-            <a:ext cx="3429000" cy="310896"/>
+            <a:off x="2404872" y="3730752"/>
+            <a:ext cx="3429000" cy="347472"/>
           </a:xfrm>
           <a:prstGeom prst="rect">
             <a:avLst/>
@@ -5156,7 +5156,7 @@
               </a:lnSpc>
             </a:pPr>
             <a:r>
-              <a:rPr sz="1350" b="1" i="0">
+              <a:rPr sz="1450" b="1" i="0">
                 <a:solidFill>
                   <a:srgbClr val="102D4D"/>
                 </a:solidFill>
@@ -5175,8 +5175,8 @@
         </p:nvSpPr>
         <p:spPr>
           <a:xfrm>
-            <a:off x="2404872" y="4133087"/>
-            <a:ext cx="3429000" cy="1225296"/>
+            <a:off x="2404872" y="4123944"/>
+            <a:ext cx="3429000" cy="1252728"/>
           </a:xfrm>
           <a:prstGeom prst="rect">
             <a:avLst/>
@@ -5191,11 +5191,11 @@
           <a:p>
             <a:pPr algn="l">
               <a:lnSpc>
-                <a:spcPct val="103000"/>
+                <a:spcPct val="102000"/>
               </a:lnSpc>
             </a:pPr>
             <a:r>
-              <a:rPr sz="1019" b="0" i="0">
+              <a:rPr sz="1170" b="0" i="0">
                 <a:solidFill>
                   <a:srgbClr val="627080"/>
                 </a:solidFill>
@@ -5327,8 +5327,8 @@
         </p:nvSpPr>
         <p:spPr>
           <a:xfrm>
-            <a:off x="7964423" y="3749039"/>
-            <a:ext cx="3429000" cy="310896"/>
+            <a:off x="7964423" y="3730752"/>
+            <a:ext cx="3429000" cy="347472"/>
           </a:xfrm>
           <a:prstGeom prst="rect">
             <a:avLst/>
@@ -5347,7 +5347,7 @@
               </a:lnSpc>
             </a:pPr>
             <a:r>
-              <a:rPr sz="1350" b="1" i="0">
+              <a:rPr sz="1450" b="1" i="0">
                 <a:solidFill>
                   <a:srgbClr val="102D4D"/>
                 </a:solidFill>
@@ -5366,8 +5366,8 @@
         </p:nvSpPr>
         <p:spPr>
           <a:xfrm>
-            <a:off x="7964423" y="4133087"/>
-            <a:ext cx="3429000" cy="1225296"/>
+            <a:off x="7964423" y="4123944"/>
+            <a:ext cx="3429000" cy="1252728"/>
           </a:xfrm>
           <a:prstGeom prst="rect">
             <a:avLst/>
@@ -5382,11 +5382,11 @@
           <a:p>
             <a:pPr algn="l">
               <a:lnSpc>
-                <a:spcPct val="103000"/>
+                <a:spcPct val="102000"/>
               </a:lnSpc>
             </a:pPr>
             <a:r>
-              <a:rPr sz="1019" b="0" i="0">
+              <a:rPr sz="1170" b="0" i="0">
                 <a:solidFill>
                   <a:srgbClr val="627080"/>
                 </a:solidFill>
@@ -5835,7 +5835,7 @@
               </a:lnSpc>
             </a:pPr>
             <a:r>
-              <a:rPr sz="1120" b="1" i="0">
+              <a:rPr sz="1250" b="1" i="0">
                 <a:solidFill>
                   <a:srgbClr val="FFFFFF"/>
                 </a:solidFill>
@@ -5874,7 +5874,7 @@
               </a:lnSpc>
             </a:pPr>
             <a:r>
-              <a:rPr sz="1150" b="0" i="0">
+              <a:rPr sz="1300" b="0" i="0">
                 <a:solidFill>
                   <a:srgbClr val="182431"/>
                 </a:solidFill>
@@ -6044,7 +6044,7 @@
               </a:lnSpc>
             </a:pPr>
             <a:r>
-              <a:rPr sz="1120" b="1" i="0">
+              <a:rPr sz="1250" b="1" i="0">
                 <a:solidFill>
                   <a:srgbClr val="FFFFFF"/>
                 </a:solidFill>
@@ -6083,7 +6083,7 @@
               </a:lnSpc>
             </a:pPr>
             <a:r>
-              <a:rPr sz="1150" b="0" i="0">
+              <a:rPr sz="1300" b="0" i="0">
                 <a:solidFill>
                   <a:srgbClr val="182431"/>
                 </a:solidFill>
@@ -6253,7 +6253,7 @@
               </a:lnSpc>
             </a:pPr>
             <a:r>
-              <a:rPr sz="1120" b="1" i="0">
+              <a:rPr sz="1250" b="1" i="0">
                 <a:solidFill>
                   <a:srgbClr val="FFFFFF"/>
                 </a:solidFill>
@@ -6292,7 +6292,7 @@
               </a:lnSpc>
             </a:pPr>
             <a:r>
-              <a:rPr sz="1150" b="0" i="0">
+              <a:rPr sz="1300" b="0" i="0">
                 <a:solidFill>
                   <a:srgbClr val="182431"/>
                 </a:solidFill>
@@ -6462,7 +6462,7 @@
               </a:lnSpc>
             </a:pPr>
             <a:r>
-              <a:rPr sz="1120" b="1" i="0">
+              <a:rPr sz="1250" b="1" i="0">
                 <a:solidFill>
                   <a:srgbClr val="FFFFFF"/>
                 </a:solidFill>
@@ -6501,7 +6501,7 @@
               </a:lnSpc>
             </a:pPr>
             <a:r>
-              <a:rPr sz="1150" b="0" i="0">
+              <a:rPr sz="1300" b="0" i="0">
                 <a:solidFill>
                   <a:srgbClr val="182431"/>
                 </a:solidFill>
@@ -6602,8 +6602,8 @@
         </p:nvSpPr>
         <p:spPr>
           <a:xfrm>
-            <a:off x="1993392" y="5102352"/>
-            <a:ext cx="3429000" cy="502920"/>
+            <a:off x="1993392" y="5074920"/>
+            <a:ext cx="3429000" cy="548640"/>
           </a:xfrm>
           <a:prstGeom prst="rect">
             <a:avLst/>
@@ -6622,7 +6622,7 @@
               </a:lnSpc>
             </a:pPr>
             <a:r>
-              <a:rPr sz="1120" b="1" i="0">
+              <a:rPr sz="1230" b="1" i="0">
                 <a:solidFill>
                   <a:srgbClr val="071A2D"/>
                 </a:solidFill>
@@ -7071,11 +7071,11 @@
           <a:p>
             <a:pPr algn="l">
               <a:lnSpc>
-                <a:spcPct val="110000"/>
+                <a:spcPct val="108000"/>
               </a:lnSpc>
             </a:pPr>
             <a:r>
-              <a:rPr sz="1450" b="0" i="0">
+              <a:rPr sz="1520" b="0" i="0">
                 <a:solidFill>
                   <a:srgbClr val="FFFFFF"/>
                 </a:solidFill>
@@ -7194,11 +7194,11 @@
           <a:p>
             <a:pPr algn="l">
               <a:lnSpc>
-                <a:spcPct val="108000"/>
+                <a:spcPct val="106000"/>
               </a:lnSpc>
             </a:pPr>
             <a:r>
-              <a:rPr sz="1380" b="0" i="0">
+              <a:rPr sz="1450" b="0" i="0">
                 <a:solidFill>
                   <a:srgbClr val="182431"/>
                 </a:solidFill>
@@ -8761,7 +8761,7 @@
         <p:spPr>
           <a:xfrm>
             <a:off x="621792" y="1399032"/>
-            <a:ext cx="2432304" cy="749808"/>
+            <a:ext cx="2267712" cy="786384"/>
           </a:xfrm>
           <a:prstGeom prst="roundRect">
             <a:avLst/>
@@ -8805,8 +8805,8 @@
         </p:nvSpPr>
         <p:spPr>
           <a:xfrm>
-            <a:off x="768096" y="1581912"/>
-            <a:ext cx="329184" cy="173736"/>
+            <a:off x="758952" y="1600200"/>
+            <a:ext cx="292608" cy="173736"/>
           </a:xfrm>
           <a:prstGeom prst="rect">
             <a:avLst/>
@@ -8825,7 +8825,7 @@
               </a:lnSpc>
             </a:pPr>
             <a:r>
-              <a:rPr sz="800" b="1" i="0">
+              <a:rPr sz="850" b="1" i="0">
                 <a:solidFill>
                   <a:srgbClr val="D7A13A"/>
                 </a:solidFill>
@@ -8844,8 +8844,8 @@
         </p:nvSpPr>
         <p:spPr>
           <a:xfrm>
-            <a:off x="1152144" y="1536192"/>
-            <a:ext cx="1755648" cy="310896"/>
+            <a:off x="1097280" y="1545336"/>
+            <a:ext cx="1627632" cy="438912"/>
           </a:xfrm>
           <a:prstGeom prst="rect">
             <a:avLst/>
@@ -8870,7 +8870,7 @@
               </a:spcAft>
             </a:pPr>
             <a:r>
-              <a:rPr sz="1080" b="1" i="0">
+              <a:rPr sz="1180" b="1" i="0">
                 <a:solidFill>
                   <a:srgbClr val="102D4D"/>
                 </a:solidFill>
@@ -8879,7 +8879,7 @@
               <a:t>The Gospel </a:t>
             </a:r>
             <a:r>
-              <a:rPr sz="1080" b="0" i="0">
+              <a:rPr sz="1180" b="0" i="0">
                 <a:solidFill>
                   <a:srgbClr val="627080"/>
                 </a:solidFill>
@@ -8898,8 +8898,8 @@
         </p:nvSpPr>
         <p:spPr>
           <a:xfrm>
-            <a:off x="3236976" y="1399032"/>
-            <a:ext cx="2432304" cy="749808"/>
+            <a:off x="3072384" y="1399032"/>
+            <a:ext cx="2267712" cy="786384"/>
           </a:xfrm>
           <a:prstGeom prst="roundRect">
             <a:avLst/>
@@ -8943,8 +8943,8 @@
         </p:nvSpPr>
         <p:spPr>
           <a:xfrm>
-            <a:off x="3383280" y="1581912"/>
-            <a:ext cx="329184" cy="173736"/>
+            <a:off x="3209544" y="1600200"/>
+            <a:ext cx="292608" cy="173736"/>
           </a:xfrm>
           <a:prstGeom prst="rect">
             <a:avLst/>
@@ -8963,7 +8963,7 @@
               </a:lnSpc>
             </a:pPr>
             <a:r>
-              <a:rPr sz="800" b="1" i="0">
+              <a:rPr sz="850" b="1" i="0">
                 <a:solidFill>
                   <a:srgbClr val="D7A13A"/>
                 </a:solidFill>
@@ -8982,8 +8982,8 @@
         </p:nvSpPr>
         <p:spPr>
           <a:xfrm>
-            <a:off x="3767328" y="1536192"/>
-            <a:ext cx="1755648" cy="310896"/>
+            <a:off x="3547872" y="1545336"/>
+            <a:ext cx="1627632" cy="438912"/>
           </a:xfrm>
           <a:prstGeom prst="rect">
             <a:avLst/>
@@ -9008,7 +9008,7 @@
               </a:spcAft>
             </a:pPr>
             <a:r>
-              <a:rPr sz="1080" b="1" i="0">
+              <a:rPr sz="1180" b="1" i="0">
                 <a:solidFill>
                   <a:srgbClr val="102D4D"/>
                 </a:solidFill>
@@ -9017,7 +9017,7 @@
               <a:t>Transformation </a:t>
             </a:r>
             <a:r>
-              <a:rPr sz="1080" b="0" i="0">
+              <a:rPr sz="1180" b="0" i="0">
                 <a:solidFill>
                   <a:srgbClr val="627080"/>
                 </a:solidFill>
@@ -9036,8 +9036,8 @@
         </p:nvSpPr>
         <p:spPr>
           <a:xfrm>
-            <a:off x="5852159" y="1399032"/>
-            <a:ext cx="2432304" cy="749808"/>
+            <a:off x="5522976" y="1399032"/>
+            <a:ext cx="2267712" cy="786384"/>
           </a:xfrm>
           <a:prstGeom prst="roundRect">
             <a:avLst/>
@@ -9081,8 +9081,8 @@
         </p:nvSpPr>
         <p:spPr>
           <a:xfrm>
-            <a:off x="5998464" y="1581912"/>
-            <a:ext cx="329184" cy="173736"/>
+            <a:off x="5660136" y="1600200"/>
+            <a:ext cx="292608" cy="173736"/>
           </a:xfrm>
           <a:prstGeom prst="rect">
             <a:avLst/>
@@ -9101,7 +9101,7 @@
               </a:lnSpc>
             </a:pPr>
             <a:r>
-              <a:rPr sz="800" b="1" i="0">
+              <a:rPr sz="850" b="1" i="0">
                 <a:solidFill>
                   <a:srgbClr val="D7A13A"/>
                 </a:solidFill>
@@ -9120,8 +9120,8 @@
         </p:nvSpPr>
         <p:spPr>
           <a:xfrm>
-            <a:off x="6382512" y="1536192"/>
-            <a:ext cx="1755648" cy="310896"/>
+            <a:off x="5998464" y="1545336"/>
+            <a:ext cx="1627632" cy="438912"/>
           </a:xfrm>
           <a:prstGeom prst="rect">
             <a:avLst/>
@@ -9146,7 +9146,7 @@
               </a:spcAft>
             </a:pPr>
             <a:r>
-              <a:rPr sz="1080" b="1" i="0">
+              <a:rPr sz="1180" b="1" i="0">
                 <a:solidFill>
                   <a:srgbClr val="102D4D"/>
                 </a:solidFill>
@@ -9155,7 +9155,7 @@
               <a:t>Equipping people </a:t>
             </a:r>
             <a:r>
-              <a:rPr sz="1080" b="0" i="0">
+              <a:rPr sz="1180" b="0" i="0">
                 <a:solidFill>
                   <a:srgbClr val="627080"/>
                 </a:solidFill>
@@ -9174,8 +9174,8 @@
         </p:nvSpPr>
         <p:spPr>
           <a:xfrm>
-            <a:off x="621792" y="2651760"/>
-            <a:ext cx="960120" cy="566928"/>
+            <a:off x="621792" y="2679192"/>
+            <a:ext cx="960120" cy="603504"/>
           </a:xfrm>
           <a:prstGeom prst="roundRect">
             <a:avLst/>
@@ -9217,8 +9217,8 @@
         </p:nvSpPr>
         <p:spPr>
           <a:xfrm>
-            <a:off x="667512" y="2825496"/>
-            <a:ext cx="868680" cy="164592"/>
+            <a:off x="658368" y="2871216"/>
+            <a:ext cx="886968" cy="173736"/>
           </a:xfrm>
           <a:prstGeom prst="rect">
             <a:avLst/>
@@ -9237,7 +9237,7 @@
               </a:lnSpc>
             </a:pPr>
             <a:r>
-              <a:rPr sz="850" b="1" i="0">
+              <a:rPr sz="1000" b="1" i="0">
                 <a:solidFill>
                   <a:srgbClr val="071A2D"/>
                 </a:solidFill>
@@ -9256,8 +9256,8 @@
         </p:nvSpPr>
         <p:spPr>
           <a:xfrm>
-            <a:off x="1627632" y="2761488"/>
-            <a:ext cx="219456" cy="256032"/>
+            <a:off x="1591056" y="2798064"/>
+            <a:ext cx="201168" cy="256032"/>
           </a:xfrm>
           <a:prstGeom prst="rect">
             <a:avLst/>
@@ -9295,8 +9295,8 @@
         </p:nvSpPr>
         <p:spPr>
           <a:xfrm>
-            <a:off x="1892808" y="2651760"/>
-            <a:ext cx="1170432" cy="566928"/>
+            <a:off x="1801368" y="2679192"/>
+            <a:ext cx="1133856" cy="603504"/>
           </a:xfrm>
           <a:prstGeom prst="roundRect">
             <a:avLst/>
@@ -9338,8 +9338,8 @@
         </p:nvSpPr>
         <p:spPr>
           <a:xfrm>
-            <a:off x="1938528" y="2825496"/>
-            <a:ext cx="1078992" cy="164592"/>
+            <a:off x="1837944" y="2871216"/>
+            <a:ext cx="1060704" cy="173736"/>
           </a:xfrm>
           <a:prstGeom prst="rect">
             <a:avLst/>
@@ -9358,7 +9358,7 @@
               </a:lnSpc>
             </a:pPr>
             <a:r>
-              <a:rPr sz="850" b="1" i="0">
+              <a:rPr sz="1000" b="1" i="0">
                 <a:solidFill>
                   <a:srgbClr val="FFFFFF"/>
                 </a:solidFill>
@@ -9377,8 +9377,8 @@
         </p:nvSpPr>
         <p:spPr>
           <a:xfrm>
-            <a:off x="3108960" y="2761488"/>
-            <a:ext cx="219456" cy="256032"/>
+            <a:off x="2944368" y="2798064"/>
+            <a:ext cx="201168" cy="256032"/>
           </a:xfrm>
           <a:prstGeom prst="rect">
             <a:avLst/>
@@ -9416,8 +9416,8 @@
         </p:nvSpPr>
         <p:spPr>
           <a:xfrm>
-            <a:off x="3374136" y="2651760"/>
-            <a:ext cx="1234440" cy="566928"/>
+            <a:off x="3154680" y="2679192"/>
+            <a:ext cx="1216152" cy="603504"/>
           </a:xfrm>
           <a:prstGeom prst="roundRect">
             <a:avLst/>
@@ -9459,8 +9459,8 @@
         </p:nvSpPr>
         <p:spPr>
           <a:xfrm>
-            <a:off x="3419856" y="2825496"/>
-            <a:ext cx="1143000" cy="164592"/>
+            <a:off x="3191256" y="2871216"/>
+            <a:ext cx="1143000" cy="173736"/>
           </a:xfrm>
           <a:prstGeom prst="rect">
             <a:avLst/>
@@ -9479,7 +9479,7 @@
               </a:lnSpc>
             </a:pPr>
             <a:r>
-              <a:rPr sz="850" b="1" i="0">
+              <a:rPr sz="1000" b="1" i="0">
                 <a:solidFill>
                   <a:srgbClr val="FFFFFF"/>
                 </a:solidFill>
@@ -9498,8 +9498,8 @@
         </p:nvSpPr>
         <p:spPr>
           <a:xfrm>
-            <a:off x="4654296" y="2761488"/>
-            <a:ext cx="219456" cy="256032"/>
+            <a:off x="4379976" y="2798064"/>
+            <a:ext cx="201168" cy="256032"/>
           </a:xfrm>
           <a:prstGeom prst="rect">
             <a:avLst/>
@@ -9537,8 +9537,8 @@
         </p:nvSpPr>
         <p:spPr>
           <a:xfrm>
-            <a:off x="4919472" y="2651760"/>
-            <a:ext cx="932688" cy="566928"/>
+            <a:off x="4590288" y="2679192"/>
+            <a:ext cx="896112" cy="603504"/>
           </a:xfrm>
           <a:prstGeom prst="roundRect">
             <a:avLst/>
@@ -9580,8 +9580,8 @@
         </p:nvSpPr>
         <p:spPr>
           <a:xfrm>
-            <a:off x="4965192" y="2825496"/>
-            <a:ext cx="841248" cy="164592"/>
+            <a:off x="4626864" y="2871216"/>
+            <a:ext cx="822960" cy="173736"/>
           </a:xfrm>
           <a:prstGeom prst="rect">
             <a:avLst/>
@@ -9600,7 +9600,7 @@
               </a:lnSpc>
             </a:pPr>
             <a:r>
-              <a:rPr sz="850" b="1" i="0">
+              <a:rPr sz="1000" b="1" i="0">
                 <a:solidFill>
                   <a:srgbClr val="FFFFFF"/>
                 </a:solidFill>
@@ -9619,8 +9619,8 @@
         </p:nvSpPr>
         <p:spPr>
           <a:xfrm>
-            <a:off x="5897880" y="2761488"/>
-            <a:ext cx="219456" cy="256032"/>
+            <a:off x="5495544" y="2798064"/>
+            <a:ext cx="201168" cy="256032"/>
           </a:xfrm>
           <a:prstGeom prst="rect">
             <a:avLst/>
@@ -9658,8 +9658,8 @@
         </p:nvSpPr>
         <p:spPr>
           <a:xfrm>
-            <a:off x="6163056" y="2651760"/>
-            <a:ext cx="1389888" cy="566928"/>
+            <a:off x="5705856" y="2679192"/>
+            <a:ext cx="1353312" cy="603504"/>
           </a:xfrm>
           <a:prstGeom prst="roundRect">
             <a:avLst/>
@@ -9701,8 +9701,8 @@
         </p:nvSpPr>
         <p:spPr>
           <a:xfrm>
-            <a:off x="6208776" y="2825496"/>
-            <a:ext cx="1298448" cy="164592"/>
+            <a:off x="5742432" y="2871216"/>
+            <a:ext cx="1280160" cy="173736"/>
           </a:xfrm>
           <a:prstGeom prst="rect">
             <a:avLst/>
@@ -9721,7 +9721,7 @@
               </a:lnSpc>
             </a:pPr>
             <a:r>
-              <a:rPr sz="720" b="1" i="0">
+              <a:rPr sz="819" b="1" i="0">
                 <a:solidFill>
                   <a:srgbClr val="FFFFFF"/>
                 </a:solidFill>
@@ -9740,8 +9740,8 @@
         </p:nvSpPr>
         <p:spPr>
           <a:xfrm>
-            <a:off x="7598664" y="2761488"/>
-            <a:ext cx="219456" cy="256032"/>
+            <a:off x="7068312" y="2798064"/>
+            <a:ext cx="201168" cy="256032"/>
           </a:xfrm>
           <a:prstGeom prst="rect">
             <a:avLst/>
@@ -9779,8 +9779,8 @@
         </p:nvSpPr>
         <p:spPr>
           <a:xfrm>
-            <a:off x="7863840" y="2651760"/>
-            <a:ext cx="932688" cy="566928"/>
+            <a:off x="7278624" y="2679192"/>
+            <a:ext cx="914400" cy="603504"/>
           </a:xfrm>
           <a:prstGeom prst="roundRect">
             <a:avLst/>
@@ -9822,8 +9822,8 @@
         </p:nvSpPr>
         <p:spPr>
           <a:xfrm>
-            <a:off x="7909560" y="2825496"/>
-            <a:ext cx="841248" cy="164592"/>
+            <a:off x="7315200" y="2871216"/>
+            <a:ext cx="841248" cy="173736"/>
           </a:xfrm>
           <a:prstGeom prst="rect">
             <a:avLst/>
@@ -9842,7 +9842,7 @@
               </a:lnSpc>
             </a:pPr>
             <a:r>
-              <a:rPr sz="850" b="1" i="0">
+              <a:rPr sz="1000" b="1" i="0">
                 <a:solidFill>
                   <a:srgbClr val="071A2D"/>
                 </a:solidFill>
@@ -9861,8 +9861,8 @@
         </p:nvCxnSpPr>
         <p:spPr>
           <a:xfrm>
-            <a:off x="8330184" y="3218688"/>
-            <a:ext cx="0" cy="484632"/>
+            <a:off x="7735824" y="3282696"/>
+            <a:ext cx="0" cy="420624"/>
           </a:xfrm>
           <a:prstGeom prst="line">
             <a:avLst/>
@@ -9896,8 +9896,8 @@
         </p:nvSpPr>
         <p:spPr>
           <a:xfrm>
-            <a:off x="640080" y="3767328"/>
-            <a:ext cx="1444752" cy="594360"/>
+            <a:off x="621792" y="3767328"/>
+            <a:ext cx="1600200" cy="621792"/>
           </a:xfrm>
           <a:prstGeom prst="roundRect">
             <a:avLst/>
@@ -9941,8 +9941,8 @@
         </p:nvSpPr>
         <p:spPr>
           <a:xfrm>
-            <a:off x="713231" y="3959352"/>
-            <a:ext cx="1298448" cy="164592"/>
+            <a:off x="694944" y="3968496"/>
+            <a:ext cx="1453896" cy="182880"/>
           </a:xfrm>
           <a:prstGeom prst="rect">
             <a:avLst/>
@@ -9961,7 +9961,7 @@
               </a:lnSpc>
             </a:pPr>
             <a:r>
-              <a:rPr sz="850" b="1" i="0">
+              <a:rPr sz="1000" b="1" i="0">
                 <a:solidFill>
                   <a:srgbClr val="102D4D"/>
                 </a:solidFill>
@@ -9980,8 +9980,8 @@
         </p:nvSpPr>
         <p:spPr>
           <a:xfrm>
-            <a:off x="2359152" y="3767328"/>
-            <a:ext cx="1444752" cy="594360"/>
+            <a:off x="2496312" y="3767328"/>
+            <a:ext cx="1600200" cy="621792"/>
           </a:xfrm>
           <a:prstGeom prst="roundRect">
             <a:avLst/>
@@ -10025,8 +10025,8 @@
         </p:nvSpPr>
         <p:spPr>
           <a:xfrm>
-            <a:off x="2432304" y="3959352"/>
-            <a:ext cx="1298448" cy="164592"/>
+            <a:off x="2569464" y="3968496"/>
+            <a:ext cx="1453896" cy="182880"/>
           </a:xfrm>
           <a:prstGeom prst="rect">
             <a:avLst/>
@@ -10045,7 +10045,7 @@
               </a:lnSpc>
             </a:pPr>
             <a:r>
-              <a:rPr sz="850" b="1" i="0">
+              <a:rPr sz="1000" b="1" i="0">
                 <a:solidFill>
                   <a:srgbClr val="102D4D"/>
                 </a:solidFill>
@@ -10064,8 +10064,8 @@
         </p:nvSpPr>
         <p:spPr>
           <a:xfrm>
-            <a:off x="4078224" y="3767328"/>
-            <a:ext cx="1444752" cy="594360"/>
+            <a:off x="4370832" y="3767328"/>
+            <a:ext cx="1600200" cy="621792"/>
           </a:xfrm>
           <a:prstGeom prst="roundRect">
             <a:avLst/>
@@ -10109,8 +10109,8 @@
         </p:nvSpPr>
         <p:spPr>
           <a:xfrm>
-            <a:off x="4151376" y="3959352"/>
-            <a:ext cx="1298448" cy="164592"/>
+            <a:off x="4443984" y="3968496"/>
+            <a:ext cx="1453896" cy="182880"/>
           </a:xfrm>
           <a:prstGeom prst="rect">
             <a:avLst/>
@@ -10129,7 +10129,7 @@
               </a:lnSpc>
             </a:pPr>
             <a:r>
-              <a:rPr sz="850" b="1" i="0">
+              <a:rPr sz="1000" b="1" i="0">
                 <a:solidFill>
                   <a:srgbClr val="102D4D"/>
                 </a:solidFill>
@@ -10148,8 +10148,8 @@
         </p:nvSpPr>
         <p:spPr>
           <a:xfrm>
-            <a:off x="5797296" y="3767328"/>
-            <a:ext cx="1444752" cy="594360"/>
+            <a:off x="6245352" y="3767328"/>
+            <a:ext cx="1600200" cy="621792"/>
           </a:xfrm>
           <a:prstGeom prst="roundRect">
             <a:avLst/>
@@ -10193,8 +10193,8 @@
         </p:nvSpPr>
         <p:spPr>
           <a:xfrm>
-            <a:off x="5870448" y="3959352"/>
-            <a:ext cx="1298448" cy="164592"/>
+            <a:off x="6318504" y="3968496"/>
+            <a:ext cx="1453896" cy="182880"/>
           </a:xfrm>
           <a:prstGeom prst="rect">
             <a:avLst/>
@@ -10213,7 +10213,7 @@
               </a:lnSpc>
             </a:pPr>
             <a:r>
-              <a:rPr sz="850" b="1" i="0">
+              <a:rPr sz="1000" b="1" i="0">
                 <a:solidFill>
                   <a:srgbClr val="102D4D"/>
                 </a:solidFill>
@@ -10232,8 +10232,8 @@
         </p:nvSpPr>
         <p:spPr>
           <a:xfrm>
-            <a:off x="621792" y="4846320"/>
-            <a:ext cx="7333488" cy="384048"/>
+            <a:off x="621792" y="4818888"/>
+            <a:ext cx="7452360" cy="411480"/>
           </a:xfrm>
           <a:prstGeom prst="rect">
             <a:avLst/>
@@ -10252,7 +10252,7 @@
               </a:lnSpc>
             </a:pPr>
             <a:r>
-              <a:rPr sz="1800" b="1" i="0">
+              <a:rPr sz="1900" b="1" i="0">
                 <a:solidFill>
                   <a:srgbClr val="102D4D"/>
                 </a:solidFill>
@@ -10272,7 +10272,7 @@
         <p:spPr>
           <a:xfrm>
             <a:off x="621792" y="5358384"/>
-            <a:ext cx="7296912" cy="548640"/>
+            <a:ext cx="7360920" cy="548640"/>
           </a:xfrm>
           <a:prstGeom prst="rect">
             <a:avLst/>
@@ -10291,7 +10291,7 @@
               </a:lnSpc>
             </a:pPr>
             <a:r>
-              <a:rPr sz="1250" b="0" i="0">
+              <a:rPr sz="1350" b="0" i="0">
                 <a:solidFill>
                   <a:srgbClr val="627080"/>
                 </a:solidFill>
@@ -10310,8 +10310,8 @@
         </p:nvSpPr>
         <p:spPr>
           <a:xfrm>
-            <a:off x="8284464" y="1389888"/>
-            <a:ext cx="3291840" cy="4846320"/>
+            <a:off x="8439912" y="1389888"/>
+            <a:ext cx="3136392" cy="4846320"/>
           </a:xfrm>
           <a:prstGeom prst="roundRect">
             <a:avLst/>
@@ -10355,15 +10355,15 @@
         </p:nvPicPr>
         <p:blipFill>
           <a:blip r:embed="rId2"/>
-          <a:srcRect l="21437" r="21437"/>
+          <a:srcRect l="22785" r="22785"/>
           <a:stretch>
             <a:fillRect/>
           </a:stretch>
         </p:blipFill>
         <p:spPr>
           <a:xfrm>
-            <a:off x="8284464" y="1389888"/>
-            <a:ext cx="3291840" cy="3246120"/>
+            <a:off x="8439912" y="1389888"/>
+            <a:ext cx="3136392" cy="3246120"/>
           </a:xfrm>
           <a:prstGeom prst="rect">
             <a:avLst/>
@@ -10378,8 +10378,8 @@
         </p:nvSpPr>
         <p:spPr>
           <a:xfrm>
-            <a:off x="8641080" y="4956048"/>
-            <a:ext cx="2578608" cy="658368"/>
+            <a:off x="8723376" y="4919472"/>
+            <a:ext cx="2569464" cy="713232"/>
           </a:xfrm>
           <a:prstGeom prst="rect">
             <a:avLst/>
@@ -10398,7 +10398,7 @@
               </a:lnSpc>
             </a:pPr>
             <a:r>
-              <a:rPr sz="1500" b="1" i="0">
+              <a:rPr sz="1600" b="1" i="0">
                 <a:solidFill>
                   <a:srgbClr val="F0CC7A"/>
                 </a:solidFill>
@@ -10418,8 +10418,8 @@
         </p:nvSpPr>
         <p:spPr>
           <a:xfrm>
-            <a:off x="8641080" y="5669280"/>
-            <a:ext cx="2578608" cy="274320"/>
+            <a:off x="8705088" y="5687568"/>
+            <a:ext cx="2606040" cy="274320"/>
           </a:xfrm>
           <a:prstGeom prst="rect">
             <a:avLst/>
@@ -10438,7 +10438,7 @@
               </a:lnSpc>
             </a:pPr>
             <a:r>
-              <a:rPr sz="1000" b="0" i="0">
+              <a:rPr sz="1120" b="0" i="0">
                 <a:solidFill>
                   <a:srgbClr val="FFFFFF"/>
                 </a:solidFill>
@@ -10889,11 +10889,11 @@
           <a:p>
             <a:pPr algn="l">
               <a:lnSpc>
-                <a:spcPct val="107000"/>
+                <a:spcPct val="105000"/>
               </a:lnSpc>
             </a:pPr>
             <a:r>
-              <a:rPr sz="1200" b="0" i="0">
+              <a:rPr sz="1320" b="0" i="0">
                 <a:solidFill>
                   <a:srgbClr val="182431"/>
                 </a:solidFill>
@@ -11080,11 +11080,11 @@
           <a:p>
             <a:pPr algn="l">
               <a:lnSpc>
-                <a:spcPct val="107000"/>
+                <a:spcPct val="105000"/>
               </a:lnSpc>
             </a:pPr>
             <a:r>
-              <a:rPr sz="1200" b="0" i="0">
+              <a:rPr sz="1320" b="0" i="0">
                 <a:solidFill>
                   <a:srgbClr val="182431"/>
                 </a:solidFill>
@@ -11271,11 +11271,11 @@
           <a:p>
             <a:pPr algn="l">
               <a:lnSpc>
-                <a:spcPct val="107000"/>
+                <a:spcPct val="105000"/>
               </a:lnSpc>
             </a:pPr>
             <a:r>
-              <a:rPr sz="1200" b="0" i="0">
+              <a:rPr sz="1320" b="0" i="0">
                 <a:solidFill>
                   <a:srgbClr val="182431"/>
                 </a:solidFill>
@@ -11462,11 +11462,11 @@
           <a:p>
             <a:pPr algn="l">
               <a:lnSpc>
-                <a:spcPct val="107000"/>
+                <a:spcPct val="105000"/>
               </a:lnSpc>
             </a:pPr>
             <a:r>
-              <a:rPr sz="1200" b="0" i="0">
+              <a:rPr sz="1320" b="0" i="0">
                 <a:solidFill>
                   <a:srgbClr val="182431"/>
                 </a:solidFill>
@@ -11831,8 +11831,8 @@
         </p:nvSpPr>
         <p:spPr>
           <a:xfrm>
-            <a:off x="621792" y="1353312"/>
-            <a:ext cx="420624" cy="420624"/>
+            <a:off x="621792" y="1344168"/>
+            <a:ext cx="438912" cy="438912"/>
           </a:xfrm>
           <a:prstGeom prst="roundRect">
             <a:avLst/>
@@ -11875,7 +11875,7 @@
         <p:spPr>
           <a:xfrm>
             <a:off x="630936" y="1472184"/>
-            <a:ext cx="402336" cy="155448"/>
+            <a:ext cx="420624" cy="164592"/>
           </a:xfrm>
           <a:prstGeom prst="rect">
             <a:avLst/>
@@ -11894,7 +11894,7 @@
               </a:lnSpc>
             </a:pPr>
             <a:r>
-              <a:rPr sz="780" b="1" i="0">
+              <a:rPr sz="850" b="1" i="0">
                 <a:solidFill>
                   <a:srgbClr val="071A2D"/>
                 </a:solidFill>
@@ -11913,8 +11913,8 @@
         </p:nvSpPr>
         <p:spPr>
           <a:xfrm>
-            <a:off x="1243584" y="1335024"/>
-            <a:ext cx="1920240" cy="228600"/>
+            <a:off x="1261872" y="1316736"/>
+            <a:ext cx="5330952" cy="548640"/>
           </a:xfrm>
           <a:prstGeom prst="rect">
             <a:avLst/>
@@ -11931,48 +11931,24 @@
               <a:lnSpc>
                 <a:spcPct val="100000"/>
               </a:lnSpc>
+              <a:spcBef>
+                <a:spcPts val="0"/>
+              </a:spcBef>
+              <a:spcAft>
+                <a:spcPts val="0"/>
+              </a:spcAft>
             </a:pPr>
             <a:r>
-              <a:rPr sz="960" b="1" i="0">
+              <a:rPr sz="1140" b="1" i="0">
                 <a:solidFill>
                   <a:srgbClr val="102D4D"/>
                 </a:solidFill>
                 <a:latin typeface="Aptos"/>
               </a:rPr>
-              <a:t>SPORT</a:t>
-            </a:r>
-          </a:p>
-        </p:txBody>
-      </p:sp>
-      <p:sp>
-        <p:nvSpPr>
-          <p:cNvPr id="9" name="TextBox 8"/>
-          <p:cNvSpPr txBox="1"/>
-          <p:nvPr/>
-        </p:nvSpPr>
-        <p:spPr>
-          <a:xfrm>
-            <a:off x="2971800" y="1325880"/>
-            <a:ext cx="3566160" cy="448056"/>
-          </a:xfrm>
-          <a:prstGeom prst="rect">
-            <a:avLst/>
-          </a:prstGeom>
-          <a:noFill/>
-        </p:spPr>
-        <p:txBody>
-          <a:bodyPr wrap="square" lIns="0" rIns="0" tIns="0" bIns="0" anchor="t">
-            <a:spAutoFit/>
-          </a:bodyPr>
-          <a:lstStyle/>
-          <a:p>
-            <a:pPr algn="l">
-              <a:lnSpc>
-                <a:spcPct val="100000"/>
-              </a:lnSpc>
-            </a:pPr>
-            <a:r>
-              <a:rPr sz="969" b="0" i="0">
+              <a:t>SPORT — </a:t>
+            </a:r>
+            <a:r>
+              <a:rPr sz="1140" b="0" i="0">
                 <a:solidFill>
                   <a:srgbClr val="627080"/>
                 </a:solidFill>
@@ -11985,14 +11961,14 @@
       </p:sp>
       <p:sp>
         <p:nvSpPr>
-          <p:cNvPr id="10" name="Rounded Rectangle 9"/>
+          <p:cNvPr id="9" name="Rounded Rectangle 8"/>
           <p:cNvSpPr/>
           <p:nvPr/>
         </p:nvSpPr>
         <p:spPr>
           <a:xfrm>
-            <a:off x="621792" y="2029968"/>
-            <a:ext cx="420624" cy="420624"/>
+            <a:off x="621792" y="2029967"/>
+            <a:ext cx="438912" cy="438912"/>
           </a:xfrm>
           <a:prstGeom prst="roundRect">
             <a:avLst/>
@@ -12028,14 +12004,14 @@
       </p:sp>
       <p:sp>
         <p:nvSpPr>
-          <p:cNvPr id="11" name="TextBox 10"/>
+          <p:cNvPr id="10" name="TextBox 9"/>
           <p:cNvSpPr txBox="1"/>
           <p:nvPr/>
         </p:nvSpPr>
         <p:spPr>
           <a:xfrm>
-            <a:off x="630936" y="2148840"/>
-            <a:ext cx="402336" cy="155448"/>
+            <a:off x="630936" y="2157984"/>
+            <a:ext cx="420624" cy="164592"/>
           </a:xfrm>
           <a:prstGeom prst="rect">
             <a:avLst/>
@@ -12054,7 +12030,7 @@
               </a:lnSpc>
             </a:pPr>
             <a:r>
-              <a:rPr sz="780" b="1" i="0">
+              <a:rPr sz="850" b="1" i="0">
                 <a:solidFill>
                   <a:srgbClr val="FFFFFF"/>
                 </a:solidFill>
@@ -12067,14 +12043,14 @@
       </p:sp>
       <p:sp>
         <p:nvSpPr>
-          <p:cNvPr id="12" name="TextBox 11"/>
+          <p:cNvPr id="11" name="TextBox 10"/>
           <p:cNvSpPr txBox="1"/>
           <p:nvPr/>
         </p:nvSpPr>
         <p:spPr>
           <a:xfrm>
-            <a:off x="1243584" y="2011680"/>
-            <a:ext cx="1920240" cy="228600"/>
+            <a:off x="1261872" y="2002536"/>
+            <a:ext cx="5330952" cy="548640"/>
           </a:xfrm>
           <a:prstGeom prst="rect">
             <a:avLst/>
@@ -12091,48 +12067,24 @@
               <a:lnSpc>
                 <a:spcPct val="100000"/>
               </a:lnSpc>
+              <a:spcBef>
+                <a:spcPts val="0"/>
+              </a:spcBef>
+              <a:spcAft>
+                <a:spcPts val="0"/>
+              </a:spcAft>
             </a:pPr>
             <a:r>
-              <a:rPr sz="960" b="1" i="0">
+              <a:rPr sz="1140" b="1" i="0">
                 <a:solidFill>
                   <a:srgbClr val="102D4D"/>
                 </a:solidFill>
                 <a:latin typeface="Aptos"/>
               </a:rPr>
-              <a:t>LITERACY</a:t>
-            </a:r>
-          </a:p>
-        </p:txBody>
-      </p:sp>
-      <p:sp>
-        <p:nvSpPr>
-          <p:cNvPr id="13" name="TextBox 12"/>
-          <p:cNvSpPr txBox="1"/>
-          <p:nvPr/>
-        </p:nvSpPr>
-        <p:spPr>
-          <a:xfrm>
-            <a:off x="2971800" y="2002536"/>
-            <a:ext cx="3566160" cy="448056"/>
-          </a:xfrm>
-          <a:prstGeom prst="rect">
-            <a:avLst/>
-          </a:prstGeom>
-          <a:noFill/>
-        </p:spPr>
-        <p:txBody>
-          <a:bodyPr wrap="square" lIns="0" rIns="0" tIns="0" bIns="0" anchor="t">
-            <a:spAutoFit/>
-          </a:bodyPr>
-          <a:lstStyle/>
-          <a:p>
-            <a:pPr algn="l">
-              <a:lnSpc>
-                <a:spcPct val="100000"/>
-              </a:lnSpc>
-            </a:pPr>
-            <a:r>
-              <a:rPr sz="969" b="0" i="0">
+              <a:t>LITERACY — </a:t>
+            </a:r>
+            <a:r>
+              <a:rPr sz="1140" b="0" i="0">
                 <a:solidFill>
                   <a:srgbClr val="627080"/>
                 </a:solidFill>
@@ -12145,14 +12097,14 @@
       </p:sp>
       <p:sp>
         <p:nvSpPr>
-          <p:cNvPr id="14" name="Rounded Rectangle 13"/>
+          <p:cNvPr id="12" name="Rounded Rectangle 11"/>
           <p:cNvSpPr/>
           <p:nvPr/>
         </p:nvSpPr>
         <p:spPr>
           <a:xfrm>
-            <a:off x="621792" y="2706624"/>
-            <a:ext cx="420624" cy="420624"/>
+            <a:off x="621792" y="2715768"/>
+            <a:ext cx="438912" cy="438912"/>
           </a:xfrm>
           <a:prstGeom prst="roundRect">
             <a:avLst/>
@@ -12188,14 +12140,14 @@
       </p:sp>
       <p:sp>
         <p:nvSpPr>
-          <p:cNvPr id="15" name="TextBox 14"/>
+          <p:cNvPr id="13" name="TextBox 12"/>
           <p:cNvSpPr txBox="1"/>
           <p:nvPr/>
         </p:nvSpPr>
         <p:spPr>
           <a:xfrm>
-            <a:off x="630936" y="2825496"/>
-            <a:ext cx="402336" cy="155448"/>
+            <a:off x="630936" y="2843784"/>
+            <a:ext cx="420624" cy="164592"/>
           </a:xfrm>
           <a:prstGeom prst="rect">
             <a:avLst/>
@@ -12214,7 +12166,7 @@
               </a:lnSpc>
             </a:pPr>
             <a:r>
-              <a:rPr sz="780" b="1" i="0">
+              <a:rPr sz="850" b="1" i="0">
                 <a:solidFill>
                   <a:srgbClr val="FFFFFF"/>
                 </a:solidFill>
@@ -12227,14 +12179,14 @@
       </p:sp>
       <p:sp>
         <p:nvSpPr>
-          <p:cNvPr id="16" name="TextBox 15"/>
+          <p:cNvPr id="14" name="TextBox 13"/>
           <p:cNvSpPr txBox="1"/>
           <p:nvPr/>
         </p:nvSpPr>
         <p:spPr>
           <a:xfrm>
-            <a:off x="1243584" y="2688336"/>
-            <a:ext cx="1920240" cy="228600"/>
+            <a:off x="1261872" y="2688336"/>
+            <a:ext cx="5330952" cy="548640"/>
           </a:xfrm>
           <a:prstGeom prst="rect">
             <a:avLst/>
@@ -12251,48 +12203,24 @@
               <a:lnSpc>
                 <a:spcPct val="100000"/>
               </a:lnSpc>
+              <a:spcBef>
+                <a:spcPts val="0"/>
+              </a:spcBef>
+              <a:spcAft>
+                <a:spcPts val="0"/>
+              </a:spcAft>
             </a:pPr>
             <a:r>
-              <a:rPr sz="960" b="1" i="0">
+              <a:rPr sz="1140" b="1" i="0">
                 <a:solidFill>
                   <a:srgbClr val="102D4D"/>
                 </a:solidFill>
                 <a:latin typeface="Aptos"/>
               </a:rPr>
-              <a:t>ACADEMIC SUPPORT</a:t>
-            </a:r>
-          </a:p>
-        </p:txBody>
-      </p:sp>
-      <p:sp>
-        <p:nvSpPr>
-          <p:cNvPr id="17" name="TextBox 16"/>
-          <p:cNvSpPr txBox="1"/>
-          <p:nvPr/>
-        </p:nvSpPr>
-        <p:spPr>
-          <a:xfrm>
-            <a:off x="2971800" y="2679192"/>
-            <a:ext cx="3566160" cy="448056"/>
-          </a:xfrm>
-          <a:prstGeom prst="rect">
-            <a:avLst/>
-          </a:prstGeom>
-          <a:noFill/>
-        </p:spPr>
-        <p:txBody>
-          <a:bodyPr wrap="square" lIns="0" rIns="0" tIns="0" bIns="0" anchor="t">
-            <a:spAutoFit/>
-          </a:bodyPr>
-          <a:lstStyle/>
-          <a:p>
-            <a:pPr algn="l">
-              <a:lnSpc>
-                <a:spcPct val="100000"/>
-              </a:lnSpc>
-            </a:pPr>
-            <a:r>
-              <a:rPr sz="969" b="0" i="0">
+              <a:t>ACADEMIC SUPPORT — </a:t>
+            </a:r>
+            <a:r>
+              <a:rPr sz="1140" b="0" i="0">
                 <a:solidFill>
                   <a:srgbClr val="627080"/>
                 </a:solidFill>
@@ -12305,14 +12233,14 @@
       </p:sp>
       <p:sp>
         <p:nvSpPr>
-          <p:cNvPr id="18" name="Rounded Rectangle 17"/>
+          <p:cNvPr id="15" name="Rounded Rectangle 14"/>
           <p:cNvSpPr/>
           <p:nvPr/>
         </p:nvSpPr>
         <p:spPr>
           <a:xfrm>
-            <a:off x="621792" y="3383279"/>
-            <a:ext cx="420624" cy="420624"/>
+            <a:off x="621792" y="3401568"/>
+            <a:ext cx="438912" cy="438912"/>
           </a:xfrm>
           <a:prstGeom prst="roundRect">
             <a:avLst/>
@@ -12348,14 +12276,14 @@
       </p:sp>
       <p:sp>
         <p:nvSpPr>
-          <p:cNvPr id="19" name="TextBox 18"/>
+          <p:cNvPr id="16" name="TextBox 15"/>
           <p:cNvSpPr txBox="1"/>
           <p:nvPr/>
         </p:nvSpPr>
         <p:spPr>
           <a:xfrm>
-            <a:off x="630936" y="3502151"/>
-            <a:ext cx="402336" cy="155448"/>
+            <a:off x="630936" y="3529584"/>
+            <a:ext cx="420624" cy="164592"/>
           </a:xfrm>
           <a:prstGeom prst="rect">
             <a:avLst/>
@@ -12374,7 +12302,7 @@
               </a:lnSpc>
             </a:pPr>
             <a:r>
-              <a:rPr sz="780" b="1" i="0">
+              <a:rPr sz="850" b="1" i="0">
                 <a:solidFill>
                   <a:srgbClr val="FFFFFF"/>
                 </a:solidFill>
@@ -12387,14 +12315,14 @@
       </p:sp>
       <p:sp>
         <p:nvSpPr>
-          <p:cNvPr id="20" name="TextBox 19"/>
+          <p:cNvPr id="17" name="TextBox 16"/>
           <p:cNvSpPr txBox="1"/>
           <p:nvPr/>
         </p:nvSpPr>
         <p:spPr>
           <a:xfrm>
-            <a:off x="1243584" y="3364991"/>
-            <a:ext cx="1920240" cy="228600"/>
+            <a:off x="1261872" y="3374136"/>
+            <a:ext cx="5330952" cy="548640"/>
           </a:xfrm>
           <a:prstGeom prst="rect">
             <a:avLst/>
@@ -12411,48 +12339,24 @@
               <a:lnSpc>
                 <a:spcPct val="100000"/>
               </a:lnSpc>
+              <a:spcBef>
+                <a:spcPts val="0"/>
+              </a:spcBef>
+              <a:spcAft>
+                <a:spcPts val="0"/>
+              </a:spcAft>
             </a:pPr>
             <a:r>
-              <a:rPr sz="960" b="1" i="0">
+              <a:rPr sz="1140" b="1" i="0">
                 <a:solidFill>
                   <a:srgbClr val="102D4D"/>
                 </a:solidFill>
                 <a:latin typeface="Aptos"/>
               </a:rPr>
-              <a:t>LANGUAGES</a:t>
-            </a:r>
-          </a:p>
-        </p:txBody>
-      </p:sp>
-      <p:sp>
-        <p:nvSpPr>
-          <p:cNvPr id="21" name="TextBox 20"/>
-          <p:cNvSpPr txBox="1"/>
-          <p:nvPr/>
-        </p:nvSpPr>
-        <p:spPr>
-          <a:xfrm>
-            <a:off x="2971800" y="3355848"/>
-            <a:ext cx="3566160" cy="448056"/>
-          </a:xfrm>
-          <a:prstGeom prst="rect">
-            <a:avLst/>
-          </a:prstGeom>
-          <a:noFill/>
-        </p:spPr>
-        <p:txBody>
-          <a:bodyPr wrap="square" lIns="0" rIns="0" tIns="0" bIns="0" anchor="t">
-            <a:spAutoFit/>
-          </a:bodyPr>
-          <a:lstStyle/>
-          <a:p>
-            <a:pPr algn="l">
-              <a:lnSpc>
-                <a:spcPct val="100000"/>
-              </a:lnSpc>
-            </a:pPr>
-            <a:r>
-              <a:rPr sz="969" b="0" i="0">
+              <a:t>LANGUAGES — </a:t>
+            </a:r>
+            <a:r>
+              <a:rPr sz="1140" b="0" i="0">
                 <a:solidFill>
                   <a:srgbClr val="627080"/>
                 </a:solidFill>
@@ -12465,14 +12369,14 @@
       </p:sp>
       <p:sp>
         <p:nvSpPr>
-          <p:cNvPr id="22" name="Rounded Rectangle 21"/>
+          <p:cNvPr id="18" name="Rounded Rectangle 17"/>
           <p:cNvSpPr/>
           <p:nvPr/>
         </p:nvSpPr>
         <p:spPr>
           <a:xfrm>
-            <a:off x="621792" y="4059935"/>
-            <a:ext cx="420624" cy="420624"/>
+            <a:off x="621792" y="4087368"/>
+            <a:ext cx="438912" cy="438912"/>
           </a:xfrm>
           <a:prstGeom prst="roundRect">
             <a:avLst/>
@@ -12508,14 +12412,14 @@
       </p:sp>
       <p:sp>
         <p:nvSpPr>
-          <p:cNvPr id="23" name="TextBox 22"/>
+          <p:cNvPr id="19" name="TextBox 18"/>
           <p:cNvSpPr txBox="1"/>
           <p:nvPr/>
         </p:nvSpPr>
         <p:spPr>
           <a:xfrm>
-            <a:off x="630936" y="4178808"/>
-            <a:ext cx="402336" cy="155448"/>
+            <a:off x="630936" y="4215383"/>
+            <a:ext cx="420624" cy="164592"/>
           </a:xfrm>
           <a:prstGeom prst="rect">
             <a:avLst/>
@@ -12534,7 +12438,7 @@
               </a:lnSpc>
             </a:pPr>
             <a:r>
-              <a:rPr sz="780" b="1" i="0">
+              <a:rPr sz="850" b="1" i="0">
                 <a:solidFill>
                   <a:srgbClr val="071A2D"/>
                 </a:solidFill>
@@ -12547,14 +12451,14 @@
       </p:sp>
       <p:sp>
         <p:nvSpPr>
-          <p:cNvPr id="24" name="TextBox 23"/>
+          <p:cNvPr id="20" name="TextBox 19"/>
           <p:cNvSpPr txBox="1"/>
           <p:nvPr/>
         </p:nvSpPr>
         <p:spPr>
           <a:xfrm>
-            <a:off x="1243584" y="4041648"/>
-            <a:ext cx="1920240" cy="228600"/>
+            <a:off x="1261872" y="4059935"/>
+            <a:ext cx="5330952" cy="548640"/>
           </a:xfrm>
           <a:prstGeom prst="rect">
             <a:avLst/>
@@ -12571,48 +12475,24 @@
               <a:lnSpc>
                 <a:spcPct val="100000"/>
               </a:lnSpc>
+              <a:spcBef>
+                <a:spcPts val="0"/>
+              </a:spcBef>
+              <a:spcAft>
+                <a:spcPts val="0"/>
+              </a:spcAft>
             </a:pPr>
             <a:r>
-              <a:rPr sz="960" b="1" i="0">
+              <a:rPr sz="1140" b="1" i="0">
                 <a:solidFill>
                   <a:srgbClr val="102D4D"/>
                 </a:solidFill>
                 <a:latin typeface="Aptos"/>
               </a:rPr>
-              <a:t>DIGITAL &amp; CODING</a:t>
-            </a:r>
-          </a:p>
-        </p:txBody>
-      </p:sp>
-      <p:sp>
-        <p:nvSpPr>
-          <p:cNvPr id="25" name="TextBox 24"/>
-          <p:cNvSpPr txBox="1"/>
-          <p:nvPr/>
-        </p:nvSpPr>
-        <p:spPr>
-          <a:xfrm>
-            <a:off x="2971800" y="4032504"/>
-            <a:ext cx="3566160" cy="448056"/>
-          </a:xfrm>
-          <a:prstGeom prst="rect">
-            <a:avLst/>
-          </a:prstGeom>
-          <a:noFill/>
-        </p:spPr>
-        <p:txBody>
-          <a:bodyPr wrap="square" lIns="0" rIns="0" tIns="0" bIns="0" anchor="t">
-            <a:spAutoFit/>
-          </a:bodyPr>
-          <a:lstStyle/>
-          <a:p>
-            <a:pPr algn="l">
-              <a:lnSpc>
-                <a:spcPct val="100000"/>
-              </a:lnSpc>
-            </a:pPr>
-            <a:r>
-              <a:rPr sz="969" b="0" i="0">
+              <a:t>DIGITAL &amp; CODING — </a:t>
+            </a:r>
+            <a:r>
+              <a:rPr sz="1140" b="0" i="0">
                 <a:solidFill>
                   <a:srgbClr val="627080"/>
                 </a:solidFill>
@@ -12625,14 +12505,14 @@
       </p:sp>
       <p:sp>
         <p:nvSpPr>
-          <p:cNvPr id="26" name="Rounded Rectangle 25"/>
+          <p:cNvPr id="21" name="Rounded Rectangle 20"/>
           <p:cNvSpPr/>
           <p:nvPr/>
         </p:nvSpPr>
         <p:spPr>
           <a:xfrm>
-            <a:off x="621792" y="4736592"/>
-            <a:ext cx="420624" cy="420624"/>
+            <a:off x="621792" y="4773168"/>
+            <a:ext cx="438912" cy="438912"/>
           </a:xfrm>
           <a:prstGeom prst="roundRect">
             <a:avLst/>
@@ -12668,14 +12548,14 @@
       </p:sp>
       <p:sp>
         <p:nvSpPr>
-          <p:cNvPr id="27" name="TextBox 26"/>
+          <p:cNvPr id="22" name="TextBox 21"/>
           <p:cNvSpPr txBox="1"/>
           <p:nvPr/>
         </p:nvSpPr>
         <p:spPr>
           <a:xfrm>
-            <a:off x="630936" y="4855464"/>
-            <a:ext cx="402336" cy="155448"/>
+            <a:off x="630936" y="4901183"/>
+            <a:ext cx="420624" cy="164592"/>
           </a:xfrm>
           <a:prstGeom prst="rect">
             <a:avLst/>
@@ -12694,7 +12574,7 @@
               </a:lnSpc>
             </a:pPr>
             <a:r>
-              <a:rPr sz="780" b="1" i="0">
+              <a:rPr sz="850" b="1" i="0">
                 <a:solidFill>
                   <a:srgbClr val="FFFFFF"/>
                 </a:solidFill>
@@ -12707,14 +12587,14 @@
       </p:sp>
       <p:sp>
         <p:nvSpPr>
-          <p:cNvPr id="28" name="TextBox 27"/>
+          <p:cNvPr id="23" name="TextBox 22"/>
           <p:cNvSpPr txBox="1"/>
           <p:nvPr/>
         </p:nvSpPr>
         <p:spPr>
           <a:xfrm>
-            <a:off x="1243584" y="4718304"/>
-            <a:ext cx="1920240" cy="228600"/>
+            <a:off x="1261872" y="4745736"/>
+            <a:ext cx="5330952" cy="548640"/>
           </a:xfrm>
           <a:prstGeom prst="rect">
             <a:avLst/>
@@ -12731,48 +12611,24 @@
               <a:lnSpc>
                 <a:spcPct val="100000"/>
               </a:lnSpc>
+              <a:spcBef>
+                <a:spcPts val="0"/>
+              </a:spcBef>
+              <a:spcAft>
+                <a:spcPts val="0"/>
+              </a:spcAft>
             </a:pPr>
             <a:r>
-              <a:rPr sz="960" b="1" i="0">
+              <a:rPr sz="1140" b="1" i="0">
                 <a:solidFill>
                   <a:srgbClr val="102D4D"/>
                 </a:solidFill>
                 <a:latin typeface="Aptos"/>
               </a:rPr>
-              <a:t>TECHNOLOGY &amp; ELECTRONICS</a:t>
-            </a:r>
-          </a:p>
-        </p:txBody>
-      </p:sp>
-      <p:sp>
-        <p:nvSpPr>
-          <p:cNvPr id="29" name="TextBox 28"/>
-          <p:cNvSpPr txBox="1"/>
-          <p:nvPr/>
-        </p:nvSpPr>
-        <p:spPr>
-          <a:xfrm>
-            <a:off x="2971800" y="4709160"/>
-            <a:ext cx="3566160" cy="448056"/>
-          </a:xfrm>
-          <a:prstGeom prst="rect">
-            <a:avLst/>
-          </a:prstGeom>
-          <a:noFill/>
-        </p:spPr>
-        <p:txBody>
-          <a:bodyPr wrap="square" lIns="0" rIns="0" tIns="0" bIns="0" anchor="t">
-            <a:spAutoFit/>
-          </a:bodyPr>
-          <a:lstStyle/>
-          <a:p>
-            <a:pPr algn="l">
-              <a:lnSpc>
-                <a:spcPct val="100000"/>
-              </a:lnSpc>
-            </a:pPr>
-            <a:r>
-              <a:rPr sz="969" b="0" i="0">
+              <a:t>TECHNOLOGY &amp; ELECTRONICS — </a:t>
+            </a:r>
+            <a:r>
+              <a:rPr sz="1140" b="0" i="0">
                 <a:solidFill>
                   <a:srgbClr val="627080"/>
                 </a:solidFill>
@@ -12785,14 +12641,14 @@
       </p:sp>
       <p:sp>
         <p:nvSpPr>
-          <p:cNvPr id="30" name="Rounded Rectangle 29"/>
+          <p:cNvPr id="24" name="Rounded Rectangle 23"/>
           <p:cNvSpPr/>
           <p:nvPr/>
         </p:nvSpPr>
         <p:spPr>
           <a:xfrm>
-            <a:off x="621792" y="5413247"/>
-            <a:ext cx="420624" cy="420624"/>
+            <a:off x="621792" y="5458968"/>
+            <a:ext cx="438912" cy="438912"/>
           </a:xfrm>
           <a:prstGeom prst="roundRect">
             <a:avLst/>
@@ -12828,14 +12684,14 @@
       </p:sp>
       <p:sp>
         <p:nvSpPr>
-          <p:cNvPr id="31" name="TextBox 30"/>
+          <p:cNvPr id="25" name="TextBox 24"/>
           <p:cNvSpPr txBox="1"/>
           <p:nvPr/>
         </p:nvSpPr>
         <p:spPr>
           <a:xfrm>
-            <a:off x="630936" y="5532120"/>
-            <a:ext cx="402336" cy="155448"/>
+            <a:off x="630936" y="5586983"/>
+            <a:ext cx="420624" cy="164592"/>
           </a:xfrm>
           <a:prstGeom prst="rect">
             <a:avLst/>
@@ -12854,7 +12710,7 @@
               </a:lnSpc>
             </a:pPr>
             <a:r>
-              <a:rPr sz="780" b="1" i="0">
+              <a:rPr sz="850" b="1" i="0">
                 <a:solidFill>
                   <a:srgbClr val="071A2D"/>
                 </a:solidFill>
@@ -12867,14 +12723,14 @@
       </p:sp>
       <p:sp>
         <p:nvSpPr>
-          <p:cNvPr id="32" name="TextBox 31"/>
+          <p:cNvPr id="26" name="TextBox 25"/>
           <p:cNvSpPr txBox="1"/>
           <p:nvPr/>
         </p:nvSpPr>
         <p:spPr>
           <a:xfrm>
-            <a:off x="1243584" y="5394959"/>
-            <a:ext cx="1920240" cy="228600"/>
+            <a:off x="1261872" y="5431536"/>
+            <a:ext cx="5330952" cy="548640"/>
           </a:xfrm>
           <a:prstGeom prst="rect">
             <a:avLst/>
@@ -12891,48 +12747,24 @@
               <a:lnSpc>
                 <a:spcPct val="100000"/>
               </a:lnSpc>
+              <a:spcBef>
+                <a:spcPts val="0"/>
+              </a:spcBef>
+              <a:spcAft>
+                <a:spcPts val="0"/>
+              </a:spcAft>
             </a:pPr>
             <a:r>
-              <a:rPr sz="960" b="1" i="0">
+              <a:rPr sz="1140" b="1" i="0">
                 <a:solidFill>
                   <a:srgbClr val="102D4D"/>
                 </a:solidFill>
                 <a:latin typeface="Aptos"/>
               </a:rPr>
-              <a:t>COOKING &amp; PASTRY</a:t>
-            </a:r>
-          </a:p>
-        </p:txBody>
-      </p:sp>
-      <p:sp>
-        <p:nvSpPr>
-          <p:cNvPr id="33" name="TextBox 32"/>
-          <p:cNvSpPr txBox="1"/>
-          <p:nvPr/>
-        </p:nvSpPr>
-        <p:spPr>
-          <a:xfrm>
-            <a:off x="2971800" y="5385816"/>
-            <a:ext cx="3566160" cy="448056"/>
-          </a:xfrm>
-          <a:prstGeom prst="rect">
-            <a:avLst/>
-          </a:prstGeom>
-          <a:noFill/>
-        </p:spPr>
-        <p:txBody>
-          <a:bodyPr wrap="square" lIns="0" rIns="0" tIns="0" bIns="0" anchor="t">
-            <a:spAutoFit/>
-          </a:bodyPr>
-          <a:lstStyle/>
-          <a:p>
-            <a:pPr algn="l">
-              <a:lnSpc>
-                <a:spcPct val="100000"/>
-              </a:lnSpc>
-            </a:pPr>
-            <a:r>
-              <a:rPr sz="969" b="0" i="0">
+              <a:t>COOKING &amp; PASTRY — </a:t>
+            </a:r>
+            <a:r>
+              <a:rPr sz="1140" b="0" i="0">
                 <a:solidFill>
                   <a:srgbClr val="627080"/>
                 </a:solidFill>
@@ -12945,7 +12777,7 @@
       </p:sp>
       <p:pic>
         <p:nvPicPr>
-          <p:cNvPr id="34" name="Picture 33" descr="sports-01.jpg"/>
+          <p:cNvPr id="27" name="Picture 26" descr="sports-01.jpg"/>
           <p:cNvPicPr>
             <a:picLocks noChangeAspect="1"/>
           </p:cNvPicPr>
@@ -12970,7 +12802,7 @@
       </p:pic>
       <p:pic>
         <p:nvPicPr>
-          <p:cNvPr id="35" name="Picture 34" descr="smf_mahambo_lit-01.jpg"/>
+          <p:cNvPr id="28" name="Picture 27" descr="smf_mahambo_lit-01.jpg"/>
           <p:cNvPicPr>
             <a:picLocks noChangeAspect="1"/>
           </p:cNvPicPr>
@@ -12995,7 +12827,7 @@
       </p:pic>
       <p:pic>
         <p:nvPicPr>
-          <p:cNvPr id="36" name="Picture 35" descr="coding-01.jpg"/>
+          <p:cNvPr id="29" name="Picture 28" descr="coding-01.jpg"/>
           <p:cNvPicPr>
             <a:picLocks noChangeAspect="1"/>
           </p:cNvPicPr>
@@ -13020,7 +12852,7 @@
       </p:pic>
       <p:pic>
         <p:nvPicPr>
-          <p:cNvPr id="37" name="Picture 36" descr="mahambo_arduino-01.jpg"/>
+          <p:cNvPr id="30" name="Picture 29" descr="mahambo_arduino-01.jpg"/>
           <p:cNvPicPr>
             <a:picLocks noChangeAspect="1"/>
           </p:cNvPicPr>
@@ -13045,7 +12877,7 @@
       </p:pic>
       <p:sp>
         <p:nvSpPr>
-          <p:cNvPr id="38" name="Rounded Rectangle 37"/>
+          <p:cNvPr id="31" name="Rounded Rectangle 30"/>
           <p:cNvSpPr/>
           <p:nvPr/>
         </p:nvSpPr>
@@ -13088,7 +12920,7 @@
       </p:sp>
       <p:sp>
         <p:nvSpPr>
-          <p:cNvPr id="39" name="TextBox 38"/>
+          <p:cNvPr id="32" name="TextBox 31"/>
           <p:cNvSpPr txBox="1"/>
           <p:nvPr/>
         </p:nvSpPr>
@@ -13127,7 +12959,7 @@
       </p:sp>
       <p:sp>
         <p:nvSpPr>
-          <p:cNvPr id="40" name="TextBox 39"/>
+          <p:cNvPr id="33" name="TextBox 32"/>
           <p:cNvSpPr txBox="1"/>
           <p:nvPr/>
         </p:nvSpPr>
@@ -13166,7 +12998,7 @@
       </p:sp>
       <p:sp>
         <p:nvSpPr>
-          <p:cNvPr id="41" name="TextBox 40"/>
+          <p:cNvPr id="34" name="TextBox 33"/>
           <p:cNvSpPr txBox="1"/>
           <p:nvPr/>
         </p:nvSpPr>

</xml_diff>

<commit_message>
Add presentation watermarks and relief photo
Co-authored-by: arena-agent <297053741+arena-agent@users.noreply.github.com>
</commit_message>
<xml_diff>
--- a/POWER POINT MANIFEST-ELYSE.pptx
+++ b/POWER POINT MANIFEST-ELYSE.pptx
@@ -4447,6 +4447,30 @@
           </a:p>
         </p:txBody>
       </p:sp>
+      <p:pic>
+        <p:nvPicPr>
+          <p:cNvPr id="12" name="Picture 11" descr="logo-watermark.png"/>
+          <p:cNvPicPr>
+            <a:picLocks noChangeAspect="1"/>
+          </p:cNvPicPr>
+          <p:nvPr/>
+        </p:nvPicPr>
+        <p:blipFill>
+          <a:blip r:embed="rId4"/>
+          <a:stretch>
+            <a:fillRect/>
+          </a:stretch>
+        </p:blipFill>
+        <p:spPr>
+          <a:xfrm>
+            <a:off x="11045952" y="128016"/>
+            <a:ext cx="530352" cy="512064"/>
+          </a:xfrm>
+          <a:prstGeom prst="rect">
+            <a:avLst/>
+          </a:prstGeom>
+        </p:spPr>
+      </p:pic>
     </p:spTree>
   </p:cSld>
   <p:clrMapOvr>
@@ -5529,6 +5553,30 @@
           </a:p>
         </p:txBody>
       </p:sp>
+      <p:pic>
+        <p:nvPicPr>
+          <p:cNvPr id="29" name="Picture 28" descr="logo-watermark.png"/>
+          <p:cNvPicPr>
+            <a:picLocks noChangeAspect="1"/>
+          </p:cNvPicPr>
+          <p:nvPr/>
+        </p:nvPicPr>
+        <p:blipFill>
+          <a:blip r:embed="rId6"/>
+          <a:stretch>
+            <a:fillRect/>
+          </a:stretch>
+        </p:blipFill>
+        <p:spPr>
+          <a:xfrm>
+            <a:off x="11045952" y="128016"/>
+            <a:ext cx="530352" cy="512064"/>
+          </a:xfrm>
+          <a:prstGeom prst="rect">
+            <a:avLst/>
+          </a:prstGeom>
+        </p:spPr>
+      </p:pic>
     </p:spTree>
   </p:cSld>
   <p:clrMapOvr>
@@ -6818,6 +6866,30 @@
           </a:p>
         </p:txBody>
       </p:sp>
+      <p:pic>
+        <p:nvPicPr>
+          <p:cNvPr id="33" name="Picture 32" descr="logo-watermark.png"/>
+          <p:cNvPicPr>
+            <a:picLocks noChangeAspect="1"/>
+          </p:cNvPicPr>
+          <p:nvPr/>
+        </p:nvPicPr>
+        <p:blipFill>
+          <a:blip r:embed="rId3"/>
+          <a:stretch>
+            <a:fillRect/>
+          </a:stretch>
+        </p:blipFill>
+        <p:spPr>
+          <a:xfrm>
+            <a:off x="11045952" y="128016"/>
+            <a:ext cx="530352" cy="512064"/>
+          </a:xfrm>
+          <a:prstGeom prst="rect">
+            <a:avLst/>
+          </a:prstGeom>
+        </p:spPr>
+      </p:pic>
     </p:spTree>
   </p:cSld>
   <p:clrMapOvr>
@@ -7387,6 +7459,30 @@
           </a:p>
         </p:txBody>
       </p:sp>
+      <p:pic>
+        <p:nvPicPr>
+          <p:cNvPr id="17" name="Picture 16" descr="logo-watermark.png"/>
+          <p:cNvPicPr>
+            <a:picLocks noChangeAspect="1"/>
+          </p:cNvPicPr>
+          <p:nvPr/>
+        </p:nvPicPr>
+        <p:blipFill>
+          <a:blip r:embed="rId6"/>
+          <a:stretch>
+            <a:fillRect/>
+          </a:stretch>
+        </p:blipFill>
+        <p:spPr>
+          <a:xfrm>
+            <a:off x="11045952" y="128016"/>
+            <a:ext cx="530352" cy="512064"/>
+          </a:xfrm>
+          <a:prstGeom prst="rect">
+            <a:avLst/>
+          </a:prstGeom>
+        </p:spPr>
+      </p:pic>
     </p:spTree>
   </p:cSld>
   <p:clrMapOvr>
@@ -8605,6 +8701,30 @@
           </a:p>
         </p:txBody>
       </p:sp>
+      <p:pic>
+        <p:nvPicPr>
+          <p:cNvPr id="32" name="Picture 31" descr="logo-watermark.png"/>
+          <p:cNvPicPr>
+            <a:picLocks noChangeAspect="1"/>
+          </p:cNvPicPr>
+          <p:nvPr/>
+        </p:nvPicPr>
+        <p:blipFill>
+          <a:blip r:embed="rId3"/>
+          <a:stretch>
+            <a:fillRect/>
+          </a:stretch>
+        </p:blipFill>
+        <p:spPr>
+          <a:xfrm>
+            <a:off x="11045952" y="128016"/>
+            <a:ext cx="530352" cy="512064"/>
+          </a:xfrm>
+          <a:prstGeom prst="rect">
+            <a:avLst/>
+          </a:prstGeom>
+        </p:spPr>
+      </p:pic>
     </p:spTree>
   </p:cSld>
   <p:clrMapOvr>
@@ -10527,6 +10647,30 @@
           </a:p>
         </p:txBody>
       </p:sp>
+      <p:pic>
+        <p:nvPicPr>
+          <p:cNvPr id="48" name="Picture 47" descr="logo-watermark.png"/>
+          <p:cNvPicPr>
+            <a:picLocks noChangeAspect="1"/>
+          </p:cNvPicPr>
+          <p:nvPr/>
+        </p:nvPicPr>
+        <p:blipFill>
+          <a:blip r:embed="rId3"/>
+          <a:stretch>
+            <a:fillRect/>
+          </a:stretch>
+        </p:blipFill>
+        <p:spPr>
+          <a:xfrm>
+            <a:off x="11045952" y="128016"/>
+            <a:ext cx="530352" cy="512064"/>
+          </a:xfrm>
+          <a:prstGeom prst="rect">
+            <a:avLst/>
+          </a:prstGeom>
+        </p:spPr>
+      </p:pic>
     </p:spTree>
   </p:cSld>
   <p:clrMapOvr>
@@ -11376,7 +11520,7 @@
       </p:sp>
       <p:pic>
         <p:nvPicPr>
-          <p:cNvPr id="23" name="Picture 22" descr="nid-group.jpg"/>
+          <p:cNvPr id="23" name="Picture 22" descr="covid-02.jpg"/>
           <p:cNvPicPr>
             <a:picLocks noChangeAspect="1"/>
           </p:cNvPicPr>
@@ -11384,7 +11528,7 @@
         </p:nvPicPr>
         <p:blipFill>
           <a:blip r:embed="rId5"/>
-          <a:srcRect l="9010" r="9010"/>
+          <a:srcRect l="19208" r="19208"/>
           <a:stretch>
             <a:fillRect/>
           </a:stretch>
@@ -11637,6 +11781,30 @@
           </a:p>
         </p:txBody>
       </p:sp>
+      <p:pic>
+        <p:nvPicPr>
+          <p:cNvPr id="30" name="Picture 29" descr="logo-watermark.png"/>
+          <p:cNvPicPr>
+            <a:picLocks noChangeAspect="1"/>
+          </p:cNvPicPr>
+          <p:nvPr/>
+        </p:nvPicPr>
+        <p:blipFill>
+          <a:blip r:embed="rId6"/>
+          <a:stretch>
+            <a:fillRect/>
+          </a:stretch>
+        </p:blipFill>
+        <p:spPr>
+          <a:xfrm>
+            <a:off x="11045952" y="128016"/>
+            <a:ext cx="530352" cy="512064"/>
+          </a:xfrm>
+          <a:prstGeom prst="rect">
+            <a:avLst/>
+          </a:prstGeom>
+        </p:spPr>
+      </p:pic>
     </p:spTree>
   </p:cSld>
   <p:clrMapOvr>
@@ -13035,6 +13203,30 @@
           </a:p>
         </p:txBody>
       </p:sp>
+      <p:pic>
+        <p:nvPicPr>
+          <p:cNvPr id="35" name="Picture 34" descr="logo-watermark.png"/>
+          <p:cNvPicPr>
+            <a:picLocks noChangeAspect="1"/>
+          </p:cNvPicPr>
+          <p:nvPr/>
+        </p:nvPicPr>
+        <p:blipFill>
+          <a:blip r:embed="rId6"/>
+          <a:stretch>
+            <a:fillRect/>
+          </a:stretch>
+        </p:blipFill>
+        <p:spPr>
+          <a:xfrm>
+            <a:off x="11045952" y="128016"/>
+            <a:ext cx="530352" cy="512064"/>
+          </a:xfrm>
+          <a:prstGeom prst="rect">
+            <a:avLst/>
+          </a:prstGeom>
+        </p:spPr>
+      </p:pic>
     </p:spTree>
   </p:cSld>
   <p:clrMapOvr>
@@ -14238,6 +14430,30 @@
           </a:p>
         </p:txBody>
       </p:sp>
+      <p:pic>
+        <p:nvPicPr>
+          <p:cNvPr id="32" name="Picture 31" descr="logo-watermark.png"/>
+          <p:cNvPicPr>
+            <a:picLocks noChangeAspect="1"/>
+          </p:cNvPicPr>
+          <p:nvPr/>
+        </p:nvPicPr>
+        <p:blipFill>
+          <a:blip r:embed="rId3"/>
+          <a:stretch>
+            <a:fillRect/>
+          </a:stretch>
+        </p:blipFill>
+        <p:spPr>
+          <a:xfrm>
+            <a:off x="11045952" y="128016"/>
+            <a:ext cx="530352" cy="512064"/>
+          </a:xfrm>
+          <a:prstGeom prst="rect">
+            <a:avLst/>
+          </a:prstGeom>
+        </p:spPr>
+      </p:pic>
     </p:spTree>
   </p:cSld>
   <p:clrMapOvr>

</xml_diff>

<commit_message>
Add PDF cover and locations slides
Co-authored-by: arena-agent <297053741+arena-agent@users.noreply.github.com>
</commit_message>
<xml_diff>
--- a/POWER POINT MANIFEST-ELYSE.pptx
+++ b/POWER POINT MANIFEST-ELYSE.pptx
@@ -5,7 +5,9 @@
     <p:sldMasterId id="2147483648" r:id="rId1"/>
   </p:sldMasterIdLst>
   <p:sldIdLst>
+    <p:sldId id="265" r:id="rId17"/>
     <p:sldId id="256" r:id="rId7"/>
+    <p:sldId id="266" r:id="rId18"/>
     <p:sldId id="257" r:id="rId9"/>
     <p:sldId id="258" r:id="rId10"/>
     <p:sldId id="259" r:id="rId11"/>
@@ -511,6 +513,146 @@
           <a:p>
             <a:r>
               <a:t>Welcome, and thank you for the opportunity to introduce MANIFEST. Our name expresses our desire to see people become who God created them to be. From Madagascar, we serve children, young people, families, and communities through the Gospel, education, practical skills, and leadership development. Today I will briefly share our vision, the realities we respond to, and how transformation can multiply from one life into an entire community.</a:t>
+            </a:r>
+          </a:p>
+        </p:txBody>
+      </p:sp>
+      <p:sp>
+        <p:nvSpPr>
+          <p:cNvPr id="4" name="Slide Number Placeholder 3"/>
+          <p:cNvSpPr>
+            <a:spLocks noGrp="1"/>
+          </p:cNvSpPr>
+          <p:nvPr>
+            <p:ph type="sldNum" idx="5" sz="quarter"/>
+          </p:nvPr>
+        </p:nvSpPr>
+        <p:spPr/>
+      </p:sp>
+    </p:spTree>
+  </p:cSld>
+  <p:clrMapOvr>
+    <a:masterClrMapping/>
+  </p:clrMapOvr>
+</p:notes>
+</file>
+
+<file path=ppt/notesSlides/notesSlide10.xml><?xml version="1.0" encoding="utf-8"?>
+<p:notes xmlns:a="http://schemas.openxmlformats.org/drawingml/2006/main" xmlns:p="http://schemas.openxmlformats.org/presentationml/2006/main" xmlns:r="http://schemas.openxmlformats.org/officeDocument/2006/relationships">
+  <p:cSld>
+    <p:spTree>
+      <p:nvGrpSpPr>
+        <p:cNvPr id="1" name=""/>
+        <p:cNvGrpSpPr/>
+        <p:nvPr/>
+      </p:nvGrpSpPr>
+      <p:grpSpPr>
+        <a:xfrm>
+          <a:off x="0" y="0"/>
+          <a:ext cx="0" cy="0"/>
+          <a:chOff x="0" y="0"/>
+          <a:chExt cx="0" cy="0"/>
+        </a:xfrm>
+      </p:grpSpPr>
+      <p:sp>
+        <p:nvSpPr>
+          <p:cNvPr id="2" name="Slide Image Placeholder 1"/>
+          <p:cNvSpPr>
+            <a:spLocks noGrp="1"/>
+          </p:cNvSpPr>
+          <p:nvPr>
+            <p:ph type="sldImg" idx="2"/>
+          </p:nvPr>
+        </p:nvSpPr>
+        <p:spPr/>
+      </p:sp>
+      <p:sp>
+        <p:nvSpPr>
+          <p:cNvPr id="3" name="Notes Placeholder 2"/>
+          <p:cNvSpPr>
+            <a:spLocks noGrp="1"/>
+          </p:cNvSpPr>
+          <p:nvPr>
+            <p:ph type="body" idx="3" sz="quarter"/>
+          </p:nvPr>
+        </p:nvSpPr>
+        <p:spPr/>
+        <p:txBody>
+          <a:bodyPr/>
+          <a:lstStyle/>
+          <a:p>
+            <a:r>
+              <a:t>Welcome to this presentation of MANIFEST in Mahambo, Madagascar. MANIFEST exists to help people grow into the fullness of who God created them to be. This opening introduces the organisation and the Malagasy context in which our ministries serve.</a:t>
+            </a:r>
+          </a:p>
+        </p:txBody>
+      </p:sp>
+      <p:sp>
+        <p:nvSpPr>
+          <p:cNvPr id="4" name="Slide Number Placeholder 3"/>
+          <p:cNvSpPr>
+            <a:spLocks noGrp="1"/>
+          </p:cNvSpPr>
+          <p:nvPr>
+            <p:ph type="sldNum" idx="5" sz="quarter"/>
+          </p:nvPr>
+        </p:nvSpPr>
+        <p:spPr/>
+      </p:sp>
+    </p:spTree>
+  </p:cSld>
+  <p:clrMapOvr>
+    <a:masterClrMapping/>
+  </p:clrMapOvr>
+</p:notes>
+</file>
+
+<file path=ppt/notesSlides/notesSlide11.xml><?xml version="1.0" encoding="utf-8"?>
+<p:notes xmlns:a="http://schemas.openxmlformats.org/drawingml/2006/main" xmlns:p="http://schemas.openxmlformats.org/presentationml/2006/main" xmlns:r="http://schemas.openxmlformats.org/officeDocument/2006/relationships">
+  <p:cSld>
+    <p:spTree>
+      <p:nvGrpSpPr>
+        <p:cNvPr id="1" name=""/>
+        <p:cNvGrpSpPr/>
+        <p:nvPr/>
+      </p:nvGrpSpPr>
+      <p:grpSpPr>
+        <a:xfrm>
+          <a:off x="0" y="0"/>
+          <a:ext cx="0" cy="0"/>
+          <a:chOff x="0" y="0"/>
+          <a:chExt cx="0" cy="0"/>
+        </a:xfrm>
+      </p:grpSpPr>
+      <p:sp>
+        <p:nvSpPr>
+          <p:cNvPr id="2" name="Slide Image Placeholder 1"/>
+          <p:cNvSpPr>
+            <a:spLocks noGrp="1"/>
+          </p:cNvSpPr>
+          <p:nvPr>
+            <p:ph type="sldImg" idx="2"/>
+          </p:nvPr>
+        </p:nvSpPr>
+        <p:spPr/>
+      </p:sp>
+      <p:sp>
+        <p:nvSpPr>
+          <p:cNvPr id="3" name="Notes Placeholder 2"/>
+          <p:cNvSpPr>
+            <a:spLocks noGrp="1"/>
+          </p:cNvSpPr>
+          <p:nvPr>
+            <p:ph type="body" idx="3" sz="quarter"/>
+          </p:nvPr>
+        </p:nvSpPr>
+        <p:spPr/>
+        <p:txBody>
+          <a:bodyPr/>
+          <a:lstStyle/>
+          <a:p>
+            <a:r>
+              <a:t>MANIFEST is a missionary association founded in 2023 and inspired by John 10:10. Our ministry is active in four Malagasy locations: Antananarivo in Analamanga, Belobaka in Bongolava, Mahambo in Analanjirofo, and Toliara, also known as Tuléar. Each location responds to local needs through a combination of Gospel ministry, education, practical skills, and community support.</a:t>
             </a:r>
           </a:p>
         </p:txBody>
@@ -4479,6 +4621,90 @@
 </p:sld>
 </file>
 
+<file path=ppt/slides/slide10.xml><?xml version="1.0" encoding="utf-8"?>
+<p:sld xmlns:a="http://schemas.openxmlformats.org/drawingml/2006/main" xmlns:p="http://schemas.openxmlformats.org/presentationml/2006/main" xmlns:r="http://schemas.openxmlformats.org/officeDocument/2006/relationships">
+  <p:cSld>
+    <p:spTree>
+      <p:nvGrpSpPr>
+        <p:cNvPr id="1" name=""/>
+        <p:cNvGrpSpPr/>
+        <p:nvPr/>
+      </p:nvGrpSpPr>
+      <p:grpSpPr/>
+      <p:pic>
+        <p:nvPicPr>
+          <p:cNvPr id="2" name="Picture 1" descr="pdf-page-1.png"/>
+          <p:cNvPicPr>
+            <a:picLocks noChangeAspect="1"/>
+          </p:cNvPicPr>
+          <p:nvPr/>
+        </p:nvPicPr>
+        <p:blipFill>
+          <a:blip r:embed="rId2"/>
+          <a:stretch>
+            <a:fillRect/>
+          </a:stretch>
+        </p:blipFill>
+        <p:spPr>
+          <a:xfrm>
+            <a:off x="0" y="0"/>
+            <a:ext cx="12191999" cy="6858000"/>
+          </a:xfrm>
+          <a:prstGeom prst="rect">
+            <a:avLst/>
+          </a:prstGeom>
+        </p:spPr>
+      </p:pic>
+    </p:spTree>
+  </p:cSld>
+  <p:clrMapOvr>
+    <a:masterClrMapping/>
+  </p:clrMapOvr>
+</p:sld>
+</file>
+
+<file path=ppt/slides/slide11.xml><?xml version="1.0" encoding="utf-8"?>
+<p:sld xmlns:a="http://schemas.openxmlformats.org/drawingml/2006/main" xmlns:p="http://schemas.openxmlformats.org/presentationml/2006/main" xmlns:r="http://schemas.openxmlformats.org/officeDocument/2006/relationships">
+  <p:cSld>
+    <p:spTree>
+      <p:nvGrpSpPr>
+        <p:cNvPr id="1" name=""/>
+        <p:cNvGrpSpPr/>
+        <p:nvPr/>
+      </p:nvGrpSpPr>
+      <p:grpSpPr/>
+      <p:pic>
+        <p:nvPicPr>
+          <p:cNvPr id="2" name="Picture 1" descr="manifest-locations.png"/>
+          <p:cNvPicPr>
+            <a:picLocks noChangeAspect="1"/>
+          </p:cNvPicPr>
+          <p:nvPr/>
+        </p:nvPicPr>
+        <p:blipFill>
+          <a:blip r:embed="rId2"/>
+          <a:stretch>
+            <a:fillRect/>
+          </a:stretch>
+        </p:blipFill>
+        <p:spPr>
+          <a:xfrm>
+            <a:off x="0" y="0"/>
+            <a:ext cx="12191999" cy="6858000"/>
+          </a:xfrm>
+          <a:prstGeom prst="rect">
+            <a:avLst/>
+          </a:prstGeom>
+        </p:spPr>
+      </p:pic>
+    </p:spTree>
+  </p:cSld>
+  <p:clrMapOvr>
+    <a:masterClrMapping/>
+  </p:clrMapOvr>
+</p:sld>
+</file>
+
 <file path=ppt/slides/slide2.xml><?xml version="1.0" encoding="utf-8"?>
 <p:sld xmlns:a="http://schemas.openxmlformats.org/drawingml/2006/main" xmlns:p="http://schemas.openxmlformats.org/presentationml/2006/main" xmlns:r="http://schemas.openxmlformats.org/officeDocument/2006/relationships">
   <p:cSld>
@@ -5548,7 +5774,7 @@
                 </a:solidFill>
                 <a:latin typeface="Aptos"/>
               </a:rPr>
-              <a:t>02</a:t>
+              <a:t>04</a:t>
             </a:r>
           </a:p>
         </p:txBody>
@@ -6861,7 +7087,7 @@
                 </a:solidFill>
                 <a:latin typeface="Aptos"/>
               </a:rPr>
-              <a:t>03</a:t>
+              <a:t>05</a:t>
             </a:r>
           </a:p>
         </p:txBody>
@@ -7454,7 +7680,7 @@
                 </a:solidFill>
                 <a:latin typeface="Aptos"/>
               </a:rPr>
-              <a:t>04</a:t>
+              <a:t>06</a:t>
             </a:r>
           </a:p>
         </p:txBody>
@@ -8696,7 +8922,7 @@
                 </a:solidFill>
                 <a:latin typeface="Aptos"/>
               </a:rPr>
-              <a:t>05</a:t>
+              <a:t>07</a:t>
             </a:r>
           </a:p>
         </p:txBody>
@@ -10642,7 +10868,7 @@
                 </a:solidFill>
                 <a:latin typeface="Aptos"/>
               </a:rPr>
-              <a:t>06</a:t>
+              <a:t>08</a:t>
             </a:r>
           </a:p>
         </p:txBody>
@@ -11776,7 +12002,7 @@
                 </a:solidFill>
                 <a:latin typeface="Aptos"/>
               </a:rPr>
-              <a:t>07</a:t>
+              <a:t>09</a:t>
             </a:r>
           </a:p>
         </p:txBody>
@@ -13198,7 +13424,7 @@
                 </a:solidFill>
                 <a:latin typeface="Aptos"/>
               </a:rPr>
-              <a:t>08</a:t>
+              <a:t>10</a:t>
             </a:r>
           </a:p>
         </p:txBody>
@@ -14425,7 +14651,7 @@
                 </a:solidFill>
                 <a:latin typeface="Aptos"/>
               </a:rPr>
-              <a:t>09</a:t>
+              <a:t>11</a:t>
             </a:r>
           </a:p>
         </p:txBody>

</xml_diff>

<commit_message>
Replace closing cross with gratitude symbol
Co-authored-by: arena-agent <297053741+arena-agent@users.noreply.github.com>
</commit_message>
<xml_diff>
--- a/POWER POINT MANIFEST-ELYSE.pptx
+++ b/POWER POINT MANIFEST-ELYSE.pptx
@@ -7458,100 +7458,14 @@
       </p:sp>
       <p:sp>
         <p:nvSpPr>
-          <p:cNvPr id="14" name="Rectangle 13"/>
-          <p:cNvSpPr/>
-          <p:nvPr/>
-        </p:nvSpPr>
-        <p:spPr>
-          <a:xfrm>
-            <a:off x="9198864" y="1344168"/>
-            <a:ext cx="118872" cy="548640"/>
-          </a:xfrm>
-          <a:prstGeom prst="rect">
-            <a:avLst/>
-          </a:prstGeom>
-          <a:solidFill>
-            <a:srgbClr val="FFFFFF"/>
-          </a:solidFill>
-          <a:ln>
-            <a:noFill/>
-          </a:ln>
-        </p:spPr>
-        <p:style>
-          <a:lnRef idx="1">
-            <a:schemeClr val="accent1"/>
-          </a:lnRef>
-          <a:fillRef idx="3">
-            <a:schemeClr val="accent1"/>
-          </a:fillRef>
-          <a:effectRef idx="2">
-            <a:schemeClr val="accent1"/>
-          </a:effectRef>
-          <a:fontRef idx="minor">
-            <a:schemeClr val="lt1"/>
-          </a:fontRef>
-        </p:style>
-        <p:txBody>
-          <a:bodyPr rtlCol="0" anchor="ctr"/>
-          <a:lstStyle/>
-          <a:p>
-            <a:pPr algn="ctr"/>
-          </a:p>
-        </p:txBody>
-      </p:sp>
-      <p:sp>
-        <p:nvSpPr>
-          <p:cNvPr id="15" name="Rectangle 14"/>
-          <p:cNvSpPr/>
-          <p:nvPr/>
-        </p:nvSpPr>
-        <p:spPr>
-          <a:xfrm>
-            <a:off x="9043416" y="1517904"/>
-            <a:ext cx="429768" cy="118872"/>
-          </a:xfrm>
-          <a:prstGeom prst="rect">
-            <a:avLst/>
-          </a:prstGeom>
-          <a:solidFill>
-            <a:srgbClr val="FFFFFF"/>
-          </a:solidFill>
-          <a:ln>
-            <a:noFill/>
-          </a:ln>
-        </p:spPr>
-        <p:style>
-          <a:lnRef idx="1">
-            <a:schemeClr val="accent1"/>
-          </a:lnRef>
-          <a:fillRef idx="3">
-            <a:schemeClr val="accent1"/>
-          </a:fillRef>
-          <a:effectRef idx="2">
-            <a:schemeClr val="accent1"/>
-          </a:effectRef>
-          <a:fontRef idx="minor">
-            <a:schemeClr val="lt1"/>
-          </a:fontRef>
-        </p:style>
-        <p:txBody>
-          <a:bodyPr rtlCol="0" anchor="ctr"/>
-          <a:lstStyle/>
-          <a:p>
-            <a:pPr algn="ctr"/>
-          </a:p>
-        </p:txBody>
-      </p:sp>
-      <p:sp>
-        <p:nvSpPr>
-          <p:cNvPr id="16" name="TextBox 15"/>
+          <p:cNvPr id="14" name="TextBox 13"/>
           <p:cNvSpPr txBox="1"/>
           <p:nvPr/>
         </p:nvSpPr>
         <p:spPr>
           <a:xfrm>
-            <a:off x="7333488" y="2331720"/>
-            <a:ext cx="3858768" cy="484632"/>
+            <a:off x="8823960" y="1307592"/>
+            <a:ext cx="868680" cy="411480"/>
           </a:xfrm>
           <a:prstGeom prst="rect">
             <a:avLst/>
@@ -7559,7 +7473,7 @@
           <a:noFill/>
         </p:spPr>
         <p:txBody>
-          <a:bodyPr wrap="square" lIns="0" rIns="0" tIns="0" bIns="0" anchor="t">
+          <a:bodyPr wrap="square" lIns="0" rIns="0" tIns="0" bIns="0" anchor="ctr">
             <a:spAutoFit/>
           </a:bodyPr>
           <a:lstStyle/>
@@ -7572,25 +7486,25 @@
             <a:r>
               <a:rPr sz="2800" b="1" i="0">
                 <a:solidFill>
-                  <a:srgbClr val="102D4D"/>
-                </a:solidFill>
-                <a:latin typeface="Aptos Display"/>
-              </a:rPr>
-              <a:t>THANK YOU</a:t>
-            </a:r>
-          </a:p>
-        </p:txBody>
-      </p:sp>
-      <p:sp>
-        <p:nvSpPr>
-          <p:cNvPr id="17" name="TextBox 16"/>
+                  <a:srgbClr val="FFFFFF"/>
+                </a:solidFill>
+                <a:latin typeface="Aptos"/>
+              </a:rPr>
+              <a:t>♥</a:t>
+            </a:r>
+          </a:p>
+        </p:txBody>
+      </p:sp>
+      <p:sp>
+        <p:nvSpPr>
+          <p:cNvPr id="15" name="TextBox 14"/>
           <p:cNvSpPr txBox="1"/>
           <p:nvPr/>
         </p:nvSpPr>
         <p:spPr>
           <a:xfrm>
-            <a:off x="7333488" y="2880360"/>
-            <a:ext cx="3858768" cy="310896"/>
+            <a:off x="7333488" y="2331720"/>
+            <a:ext cx="3858768" cy="484632"/>
           </a:xfrm>
           <a:prstGeom prst="rect">
             <a:avLst/>
@@ -7609,6 +7523,45 @@
               </a:lnSpc>
             </a:pPr>
             <a:r>
+              <a:rPr sz="2800" b="1" i="0">
+                <a:solidFill>
+                  <a:srgbClr val="102D4D"/>
+                </a:solidFill>
+                <a:latin typeface="Aptos Display"/>
+              </a:rPr>
+              <a:t>THANK YOU</a:t>
+            </a:r>
+          </a:p>
+        </p:txBody>
+      </p:sp>
+      <p:sp>
+        <p:nvSpPr>
+          <p:cNvPr id="16" name="TextBox 15"/>
+          <p:cNvSpPr txBox="1"/>
+          <p:nvPr/>
+        </p:nvSpPr>
+        <p:spPr>
+          <a:xfrm>
+            <a:off x="7333488" y="2880360"/>
+            <a:ext cx="3858768" cy="310896"/>
+          </a:xfrm>
+          <a:prstGeom prst="rect">
+            <a:avLst/>
+          </a:prstGeom>
+          <a:noFill/>
+        </p:spPr>
+        <p:txBody>
+          <a:bodyPr wrap="square" lIns="0" rIns="0" tIns="0" bIns="0" anchor="t">
+            <a:spAutoFit/>
+          </a:bodyPr>
+          <a:lstStyle/>
+          <a:p>
+            <a:pPr algn="ctr">
+              <a:lnSpc>
+                <a:spcPct val="100000"/>
+              </a:lnSpc>
+            </a:pPr>
+            <a:r>
               <a:rPr sz="1400" b="1" i="0">
                 <a:solidFill>
                   <a:srgbClr val="D7A13A"/>
@@ -7622,7 +7575,7 @@
       </p:sp>
       <p:sp>
         <p:nvSpPr>
-          <p:cNvPr id="18" name="TextBox 17"/>
+          <p:cNvPr id="17" name="TextBox 16"/>
           <p:cNvSpPr txBox="1"/>
           <p:nvPr/>
         </p:nvSpPr>
@@ -7662,7 +7615,7 @@
       </p:sp>
       <p:sp>
         <p:nvSpPr>
-          <p:cNvPr id="19" name="Rectangle 18"/>
+          <p:cNvPr id="18" name="Rectangle 17"/>
           <p:cNvSpPr/>
           <p:nvPr/>
         </p:nvSpPr>
@@ -7705,7 +7658,7 @@
       </p:sp>
       <p:sp>
         <p:nvSpPr>
-          <p:cNvPr id="20" name="TextBox 19"/>
+          <p:cNvPr id="19" name="TextBox 18"/>
           <p:cNvSpPr txBox="1"/>
           <p:nvPr/>
         </p:nvSpPr>
@@ -7745,7 +7698,7 @@
       </p:sp>
       <p:sp>
         <p:nvSpPr>
-          <p:cNvPr id="21" name="TextBox 20"/>
+          <p:cNvPr id="20" name="TextBox 19"/>
           <p:cNvSpPr txBox="1"/>
           <p:nvPr/>
         </p:nvSpPr>
@@ -7784,7 +7737,7 @@
       </p:sp>
       <p:sp>
         <p:nvSpPr>
-          <p:cNvPr id="22" name="TextBox 21"/>
+          <p:cNvPr id="21" name="TextBox 20"/>
           <p:cNvSpPr txBox="1"/>
           <p:nvPr/>
         </p:nvSpPr>
@@ -7823,7 +7776,7 @@
       </p:sp>
       <p:sp>
         <p:nvSpPr>
-          <p:cNvPr id="23" name="TextBox 22"/>
+          <p:cNvPr id="22" name="TextBox 21"/>
           <p:cNvSpPr txBox="1"/>
           <p:nvPr/>
         </p:nvSpPr>
@@ -7862,7 +7815,7 @@
       </p:sp>
       <p:pic>
         <p:nvPicPr>
-          <p:cNvPr id="24" name="Picture 23" descr="image.png"/>
+          <p:cNvPr id="23" name="Picture 22" descr="image.png"/>
           <p:cNvPicPr>
             <a:picLocks noChangeAspect="1"/>
           </p:cNvPicPr>

</xml_diff>

<commit_message>
Redesign MANIFEST story and curate programme photography
Co-authored-by: arena-agent <297053741+arena-agent@users.noreply.github.com>
</commit_message>
<xml_diff>
--- a/POWER POINT MANIFEST-ELYSE.pptx
+++ b/POWER POINT MANIFEST-ELYSE.pptx
@@ -863,7 +863,7 @@
           <a:lstStyle/>
           <a:p>
             <a:r>
-              <a:t>The name MANIFEST carries our identity and method. MAN reminds us that every person is created in God’s image. INTO describes a journey of becoming; transformation takes time and relationship. THE FULLEST points toward God’s purpose for each life. ESTEEM means knowing our God-given value and dignity. Together, MANIFEST describes people becoming who God created them to be through the transforming power of the Gospel. This understanding shapes every class, activity, and relationship.</a:t>
+              <a:t>The name MANIFEST carries our identity and maps a journey from identity to purpose. MAN reminds us that every person is created in God’s image. INTO describes a journey of becoming; transformation takes time and relationship. THE FULLEST points toward God’s purpose for each life. ESTEEM means knowing our God-given value and dignity. Together, MANIFEST describes people becoming who God created them to be through the transforming power of the Gospel. This is why every programme begins with the person—not the problem.</a:t>
             </a:r>
           </a:p>
         </p:txBody>
@@ -9426,14 +9426,186 @@
       <p:grpSpPr/>
       <p:sp>
         <p:nvSpPr>
-          <p:cNvPr id="2" name="TextBox 1"/>
+          <p:cNvPr id="2" name="Rectangle 1"/>
+          <p:cNvSpPr/>
+          <p:nvPr/>
+        </p:nvSpPr>
+        <p:spPr>
+          <a:xfrm>
+            <a:off x="0" y="0"/>
+            <a:ext cx="12191695" cy="6858000"/>
+          </a:xfrm>
+          <a:prstGeom prst="rect">
+            <a:avLst/>
+          </a:prstGeom>
+          <a:solidFill>
+            <a:srgbClr val="071A2D"/>
+          </a:solidFill>
+          <a:ln>
+            <a:noFill/>
+          </a:ln>
+        </p:spPr>
+        <p:style>
+          <a:lnRef idx="1">
+            <a:schemeClr val="accent1"/>
+          </a:lnRef>
+          <a:fillRef idx="3">
+            <a:schemeClr val="accent1"/>
+          </a:fillRef>
+          <a:effectRef idx="2">
+            <a:schemeClr val="accent1"/>
+          </a:effectRef>
+          <a:fontRef idx="minor">
+            <a:schemeClr val="lt1"/>
+          </a:fontRef>
+        </p:style>
+        <p:txBody>
+          <a:bodyPr rtlCol="0" anchor="ctr"/>
+          <a:lstStyle/>
+          <a:p>
+            <a:pPr algn="ctr"/>
+          </a:p>
+        </p:txBody>
+      </p:sp>
+      <p:sp>
+        <p:nvSpPr>
+          <p:cNvPr id="3" name="Oval 2"/>
+          <p:cNvSpPr/>
+          <p:nvPr/>
+        </p:nvSpPr>
+        <p:spPr>
+          <a:xfrm>
+            <a:off x="8887968" y="-1444752"/>
+            <a:ext cx="4800600" cy="4800600"/>
+          </a:xfrm>
+          <a:prstGeom prst="ellipse">
+            <a:avLst/>
+          </a:prstGeom>
+          <a:noFill/>
+          <a:ln w="17780">
+            <a:solidFill>
+              <a:srgbClr val="183E64"/>
+            </a:solidFill>
+          </a:ln>
+        </p:spPr>
+        <p:style>
+          <a:lnRef idx="1">
+            <a:schemeClr val="accent1"/>
+          </a:lnRef>
+          <a:fillRef idx="3">
+            <a:schemeClr val="accent1"/>
+          </a:fillRef>
+          <a:effectRef idx="2">
+            <a:schemeClr val="accent1"/>
+          </a:effectRef>
+          <a:fontRef idx="minor">
+            <a:schemeClr val="lt1"/>
+          </a:fontRef>
+        </p:style>
+        <p:txBody>
+          <a:bodyPr rtlCol="0" anchor="ctr"/>
+          <a:lstStyle/>
+          <a:p>
+            <a:pPr algn="ctr"/>
+          </a:p>
+        </p:txBody>
+      </p:sp>
+      <p:sp>
+        <p:nvSpPr>
+          <p:cNvPr id="4" name="Oval 3"/>
+          <p:cNvSpPr/>
+          <p:nvPr/>
+        </p:nvSpPr>
+        <p:spPr>
+          <a:xfrm>
+            <a:off x="9299448" y="-1033271"/>
+            <a:ext cx="3977639" cy="3977639"/>
+          </a:xfrm>
+          <a:prstGeom prst="ellipse">
+            <a:avLst/>
+          </a:prstGeom>
+          <a:noFill/>
+          <a:ln w="12700">
+            <a:solidFill>
+              <a:srgbClr val="183E64"/>
+            </a:solidFill>
+          </a:ln>
+        </p:spPr>
+        <p:style>
+          <a:lnRef idx="1">
+            <a:schemeClr val="accent1"/>
+          </a:lnRef>
+          <a:fillRef idx="3">
+            <a:schemeClr val="accent1"/>
+          </a:fillRef>
+          <a:effectRef idx="2">
+            <a:schemeClr val="accent1"/>
+          </a:effectRef>
+          <a:fontRef idx="minor">
+            <a:schemeClr val="lt1"/>
+          </a:fontRef>
+        </p:style>
+        <p:txBody>
+          <a:bodyPr rtlCol="0" anchor="ctr"/>
+          <a:lstStyle/>
+          <a:p>
+            <a:pPr algn="ctr"/>
+          </a:p>
+        </p:txBody>
+      </p:sp>
+      <p:sp>
+        <p:nvSpPr>
+          <p:cNvPr id="5" name="Oval 4"/>
+          <p:cNvSpPr/>
+          <p:nvPr/>
+        </p:nvSpPr>
+        <p:spPr>
+          <a:xfrm>
+            <a:off x="-1783080" y="5065776"/>
+            <a:ext cx="2926080" cy="2926080"/>
+          </a:xfrm>
+          <a:prstGeom prst="ellipse">
+            <a:avLst/>
+          </a:prstGeom>
+          <a:noFill/>
+          <a:ln w="12700">
+            <a:solidFill>
+              <a:srgbClr val="183E64"/>
+            </a:solidFill>
+          </a:ln>
+        </p:spPr>
+        <p:style>
+          <a:lnRef idx="1">
+            <a:schemeClr val="accent1"/>
+          </a:lnRef>
+          <a:fillRef idx="3">
+            <a:schemeClr val="accent1"/>
+          </a:fillRef>
+          <a:effectRef idx="2">
+            <a:schemeClr val="accent1"/>
+          </a:effectRef>
+          <a:fontRef idx="minor">
+            <a:schemeClr val="lt1"/>
+          </a:fontRef>
+        </p:style>
+        <p:txBody>
+          <a:bodyPr rtlCol="0" anchor="ctr"/>
+          <a:lstStyle/>
+          <a:p>
+            <a:pPr algn="ctr"/>
+          </a:p>
+        </p:txBody>
+      </p:sp>
+      <p:sp>
+        <p:nvSpPr>
+          <p:cNvPr id="6" name="TextBox 5"/>
           <p:cNvSpPr txBox="1"/>
           <p:nvPr/>
         </p:nvSpPr>
         <p:spPr>
           <a:xfrm>
             <a:off x="621792" y="347472"/>
-            <a:ext cx="4480560" cy="201168"/>
+            <a:ext cx="4480560" cy="210312"/>
           </a:xfrm>
           <a:prstGeom prst="rect">
             <a:avLst/>
@@ -9447,70 +9619,34 @@
           <a:lstStyle/>
           <a:p>
             <a:pPr algn="l">
-              <a:lnSpc>
-                <a:spcPct val="100000"/>
-              </a:lnSpc>
+              <a:spcBef>
+                <a:spcPts val="0"/>
+              </a:spcBef>
+              <a:spcAft>
+                <a:spcPts val="0"/>
+              </a:spcAft>
             </a:pPr>
             <a:r>
               <a:rPr sz="850" b="1" i="0">
                 <a:solidFill>
-                  <a:srgbClr val="D7A13A"/>
+                  <a:srgbClr val="F0CC7A"/>
                 </a:solidFill>
                 <a:latin typeface="Aptos"/>
               </a:rPr>
-              <a:t>OUR NAME • OUR IDENTITY</a:t>
-            </a:r>
-          </a:p>
-        </p:txBody>
-      </p:sp>
-      <p:sp>
-        <p:nvSpPr>
-          <p:cNvPr id="3" name="TextBox 2"/>
-          <p:cNvSpPr txBox="1"/>
-          <p:nvPr/>
-        </p:nvSpPr>
-        <p:spPr>
-          <a:xfrm>
-            <a:off x="621792" y="621792"/>
-            <a:ext cx="10881360" cy="530352"/>
-          </a:xfrm>
-          <a:prstGeom prst="rect">
-            <a:avLst/>
-          </a:prstGeom>
-          <a:noFill/>
-        </p:spPr>
-        <p:txBody>
-          <a:bodyPr wrap="square" lIns="0" rIns="0" tIns="0" bIns="0" anchor="t">
-            <a:spAutoFit/>
-          </a:bodyPr>
-          <a:lstStyle/>
-          <a:p>
-            <a:pPr algn="l">
-              <a:lnSpc>
-                <a:spcPct val="100000"/>
-              </a:lnSpc>
-            </a:pPr>
-            <a:r>
-              <a:rPr sz="2900" b="1" i="0">
-                <a:solidFill>
-                  <a:srgbClr val="102D4D"/>
-                </a:solidFill>
-                <a:latin typeface="Aptos Display"/>
-              </a:rPr>
-              <a:t>What does MANIFEST mean?</a:t>
-            </a:r>
-          </a:p>
-        </p:txBody>
-      </p:sp>
-      <p:sp>
-        <p:nvSpPr>
-          <p:cNvPr id="4" name="Rectangle 3"/>
+              <a:t>OUR NAME  •  OUR IDENTITY</a:t>
+            </a:r>
+          </a:p>
+        </p:txBody>
+      </p:sp>
+      <p:sp>
+        <p:nvSpPr>
+          <p:cNvPr id="7" name="Rectangle 6"/>
           <p:cNvSpPr/>
           <p:nvPr/>
         </p:nvSpPr>
         <p:spPr>
           <a:xfrm>
-            <a:off x="621792" y="1170432"/>
+            <a:off x="621792" y="685800"/>
             <a:ext cx="530352" cy="32004"/>
           </a:xfrm>
           <a:prstGeom prst="rect">
@@ -9547,20 +9683,235 @@
       </p:sp>
       <p:sp>
         <p:nvSpPr>
-          <p:cNvPr id="5" name="Rounded Rectangle 4"/>
+          <p:cNvPr id="8" name="TextBox 7"/>
+          <p:cNvSpPr txBox="1"/>
+          <p:nvPr/>
+        </p:nvSpPr>
+        <p:spPr>
+          <a:xfrm>
+            <a:off x="4352544" y="402336"/>
+            <a:ext cx="6126480" cy="219456"/>
+          </a:xfrm>
+          <a:prstGeom prst="rect">
+            <a:avLst/>
+          </a:prstGeom>
+          <a:noFill/>
+        </p:spPr>
+        <p:txBody>
+          <a:bodyPr wrap="square" lIns="0" rIns="0" tIns="0" bIns="0" anchor="t">
+            <a:spAutoFit/>
+          </a:bodyPr>
+          <a:lstStyle/>
+          <a:p>
+            <a:pPr algn="l">
+              <a:spcBef>
+                <a:spcPts val="0"/>
+              </a:spcBef>
+              <a:spcAft>
+                <a:spcPts val="0"/>
+              </a:spcAft>
+            </a:pPr>
+            <a:r>
+              <a:rPr sz="819" b="1" i="0">
+                <a:solidFill>
+                  <a:srgbClr val="D8E1E8"/>
+                </a:solidFill>
+                <a:latin typeface="Aptos"/>
+              </a:rPr>
+              <a:t>A NAME THAT MAPS A JOURNEY FROM IDENTITY TO PURPOSE</a:t>
+            </a:r>
+          </a:p>
+        </p:txBody>
+      </p:sp>
+      <p:sp>
+        <p:nvSpPr>
+          <p:cNvPr id="9" name="TextBox 8"/>
+          <p:cNvSpPr txBox="1"/>
+          <p:nvPr/>
+        </p:nvSpPr>
+        <p:spPr>
+          <a:xfrm>
+            <a:off x="621792" y="1005840"/>
+            <a:ext cx="3273552" cy="1883664"/>
+          </a:xfrm>
+          <a:prstGeom prst="rect">
+            <a:avLst/>
+          </a:prstGeom>
+          <a:noFill/>
+        </p:spPr>
+        <p:txBody>
+          <a:bodyPr wrap="square" lIns="0" rIns="0" tIns="0" bIns="0">
+            <a:spAutoFit/>
+          </a:bodyPr>
+          <a:lstStyle/>
+          <a:p>
+            <a:pPr>
+              <a:lnSpc>
+                <a:spcPct val="91000"/>
+              </a:lnSpc>
+              <a:spcBef>
+                <a:spcPts val="0"/>
+              </a:spcBef>
+              <a:spcAft>
+                <a:spcPts val="0"/>
+              </a:spcAft>
+            </a:pPr>
+            <a:r>
+              <a:rPr sz="2100" b="1">
+                <a:solidFill>
+                  <a:srgbClr val="FFFFFF"/>
+                </a:solidFill>
+                <a:latin typeface="Aptos Display"/>
+              </a:rPr>
+              <a:t>WHAT DOES</a:t>
+            </a:r>
+          </a:p>
+          <a:p>
+            <a:pPr>
+              <a:lnSpc>
+                <a:spcPct val="91000"/>
+              </a:lnSpc>
+              <a:spcBef>
+                <a:spcPts val="0"/>
+              </a:spcBef>
+              <a:spcAft>
+                <a:spcPts val="0"/>
+              </a:spcAft>
+            </a:pPr>
+            <a:r>
+              <a:rPr sz="3500" b="1">
+                <a:solidFill>
+                  <a:srgbClr val="F0CC7A"/>
+                </a:solidFill>
+                <a:latin typeface="Aptos Display"/>
+              </a:rPr>
+              <a:t>MANIFEST</a:t>
+            </a:r>
+          </a:p>
+          <a:p>
+            <a:pPr>
+              <a:lnSpc>
+                <a:spcPct val="91000"/>
+              </a:lnSpc>
+              <a:spcBef>
+                <a:spcPts val="0"/>
+              </a:spcBef>
+              <a:spcAft>
+                <a:spcPts val="0"/>
+              </a:spcAft>
+            </a:pPr>
+            <a:r>
+              <a:rPr sz="2100" b="1">
+                <a:solidFill>
+                  <a:srgbClr val="FFFFFF"/>
+                </a:solidFill>
+                <a:latin typeface="Aptos Display"/>
+              </a:rPr>
+              <a:t>MEAN?</a:t>
+            </a:r>
+          </a:p>
+        </p:txBody>
+      </p:sp>
+      <p:sp>
+        <p:nvSpPr>
+          <p:cNvPr id="10" name="TextBox 9"/>
+          <p:cNvSpPr txBox="1"/>
+          <p:nvPr/>
+        </p:nvSpPr>
+        <p:spPr>
+          <a:xfrm>
+            <a:off x="640080" y="3054096"/>
+            <a:ext cx="3108960" cy="969264"/>
+          </a:xfrm>
+          <a:prstGeom prst="rect">
+            <a:avLst/>
+          </a:prstGeom>
+          <a:noFill/>
+        </p:spPr>
+        <p:txBody>
+          <a:bodyPr wrap="square" lIns="0" rIns="0" tIns="0" bIns="0" anchor="ctr">
+            <a:spAutoFit/>
+          </a:bodyPr>
+          <a:lstStyle/>
+          <a:p>
+            <a:pPr algn="l">
+              <a:spcBef>
+                <a:spcPts val="0"/>
+              </a:spcBef>
+              <a:spcAft>
+                <a:spcPts val="0"/>
+              </a:spcAft>
+            </a:pPr>
+            <a:r>
+              <a:rPr sz="1320" b="0" i="0">
+                <a:solidFill>
+                  <a:srgbClr val="D8E1E8"/>
+                </a:solidFill>
+                <a:latin typeface="Aptos"/>
+              </a:rPr>
+              <a:t>Our name describes a journey: people discovering their God-given identity, growing into purpose and living with dignity.</a:t>
+            </a:r>
+          </a:p>
+        </p:txBody>
+      </p:sp>
+      <p:sp>
+        <p:nvSpPr>
+          <p:cNvPr id="11" name="TextBox 10"/>
+          <p:cNvSpPr txBox="1"/>
+          <p:nvPr/>
+        </p:nvSpPr>
+        <p:spPr>
+          <a:xfrm>
+            <a:off x="640080" y="4288536"/>
+            <a:ext cx="3063240" cy="310896"/>
+          </a:xfrm>
+          <a:prstGeom prst="rect">
+            <a:avLst/>
+          </a:prstGeom>
+          <a:noFill/>
+        </p:spPr>
+        <p:txBody>
+          <a:bodyPr wrap="square" lIns="0" rIns="0" tIns="0" bIns="0" anchor="t">
+            <a:spAutoFit/>
+          </a:bodyPr>
+          <a:lstStyle/>
+          <a:p>
+            <a:pPr algn="l">
+              <a:spcBef>
+                <a:spcPts val="0"/>
+              </a:spcBef>
+              <a:spcAft>
+                <a:spcPts val="0"/>
+              </a:spcAft>
+            </a:pPr>
+            <a:r>
+              <a:rPr sz="1080" b="1" i="0">
+                <a:solidFill>
+                  <a:srgbClr val="F0CC7A"/>
+                </a:solidFill>
+                <a:latin typeface="Aptos"/>
+              </a:rPr>
+              <a:t>IDENTITY.  PURPOSE.  DIGNITY.</a:t>
+            </a:r>
+          </a:p>
+        </p:txBody>
+      </p:sp>
+      <p:sp>
+        <p:nvSpPr>
+          <p:cNvPr id="12" name="Rectangle 11"/>
           <p:cNvSpPr/>
           <p:nvPr/>
         </p:nvSpPr>
         <p:spPr>
           <a:xfrm>
-            <a:off x="621792" y="1463040"/>
-            <a:ext cx="5138928" cy="658368"/>
-          </a:xfrm>
-          <a:prstGeom prst="roundRect">
+            <a:off x="640080" y="4745736"/>
+            <a:ext cx="2816352" cy="14630"/>
+          </a:xfrm>
+          <a:prstGeom prst="rect">
             <a:avLst/>
           </a:prstGeom>
           <a:solidFill>
-            <a:srgbClr val="DDE4E9"/>
+            <a:srgbClr val="183E64"/>
           </a:solidFill>
           <a:ln>
             <a:noFill/>
@@ -9590,24 +9941,69 @@
       </p:sp>
       <p:sp>
         <p:nvSpPr>
-          <p:cNvPr id="6" name="Rounded Rectangle 5"/>
+          <p:cNvPr id="13" name="TextBox 12"/>
+          <p:cNvSpPr txBox="1"/>
+          <p:nvPr/>
+        </p:nvSpPr>
+        <p:spPr>
+          <a:xfrm>
+            <a:off x="640080" y="4946904"/>
+            <a:ext cx="3035808" cy="749808"/>
+          </a:xfrm>
+          <a:prstGeom prst="rect">
+            <a:avLst/>
+          </a:prstGeom>
+          <a:noFill/>
+        </p:spPr>
+        <p:txBody>
+          <a:bodyPr wrap="square" lIns="0" rIns="0" tIns="0" bIns="0" anchor="t">
+            <a:spAutoFit/>
+          </a:bodyPr>
+          <a:lstStyle/>
+          <a:p>
+            <a:pPr algn="l">
+              <a:spcBef>
+                <a:spcPts val="0"/>
+              </a:spcBef>
+              <a:spcAft>
+                <a:spcPts val="0"/>
+              </a:spcAft>
+            </a:pPr>
+            <a:r>
+              <a:rPr sz="919" b="0" i="1">
+                <a:solidFill>
+                  <a:srgbClr val="D8E1E8"/>
+                </a:solidFill>
+                <a:latin typeface="Aptos"/>
+              </a:rPr>
+              <a:t>“I have come that they may have life, and have it abundantly.”
+JOHN 10:10</a:t>
+            </a:r>
+          </a:p>
+        </p:txBody>
+      </p:sp>
+      <p:sp>
+        <p:nvSpPr>
+          <p:cNvPr id="14" name="Rounded Rectangle 13"/>
           <p:cNvSpPr/>
           <p:nvPr/>
         </p:nvSpPr>
         <p:spPr>
           <a:xfrm>
-            <a:off x="576072" y="1417320"/>
-            <a:ext cx="5138928" cy="658368"/>
+            <a:off x="4352544" y="950976"/>
+            <a:ext cx="3383280" cy="1325880"/>
           </a:xfrm>
           <a:prstGeom prst="roundRect">
-            <a:avLst/>
+            <a:avLst>
+              <a:gd name="adj" fmla="val 8000"/>
+            </a:avLst>
           </a:prstGeom>
           <a:solidFill>
-            <a:srgbClr val="FFFFFF"/>
+            <a:srgbClr val="F7F4EE"/>
           </a:solidFill>
-          <a:ln w="8890">
+          <a:ln w="10160">
             <a:solidFill>
-              <a:srgbClr val="E7E1D7"/>
+              <a:srgbClr val="E4DCCE"/>
             </a:solidFill>
           </a:ln>
         </p:spPr>
@@ -9635,764 +10031,16 @@
       </p:sp>
       <p:sp>
         <p:nvSpPr>
-          <p:cNvPr id="7" name="Rounded Rectangle 6"/>
+          <p:cNvPr id="15" name="Rectangle 14"/>
           <p:cNvSpPr/>
           <p:nvPr/>
         </p:nvSpPr>
         <p:spPr>
           <a:xfrm>
-            <a:off x="576072" y="1417320"/>
-            <a:ext cx="1481328" cy="658368"/>
-          </a:xfrm>
-          <a:prstGeom prst="roundRect">
-            <a:avLst/>
-          </a:prstGeom>
-          <a:solidFill>
-            <a:srgbClr val="102D4D"/>
-          </a:solidFill>
-          <a:ln>
-            <a:noFill/>
-          </a:ln>
-        </p:spPr>
-        <p:style>
-          <a:lnRef idx="1">
-            <a:schemeClr val="accent1"/>
-          </a:lnRef>
-          <a:fillRef idx="3">
-            <a:schemeClr val="accent1"/>
-          </a:fillRef>
-          <a:effectRef idx="2">
-            <a:schemeClr val="accent1"/>
-          </a:effectRef>
-          <a:fontRef idx="minor">
-            <a:schemeClr val="lt1"/>
-          </a:fontRef>
-        </p:style>
-        <p:txBody>
-          <a:bodyPr rtlCol="0" anchor="ctr"/>
-          <a:lstStyle/>
-          <a:p>
-            <a:pPr algn="ctr"/>
-          </a:p>
-        </p:txBody>
-      </p:sp>
-      <p:sp>
-        <p:nvSpPr>
-          <p:cNvPr id="8" name="TextBox 7"/>
-          <p:cNvSpPr txBox="1"/>
-          <p:nvPr/>
-        </p:nvSpPr>
-        <p:spPr>
-          <a:xfrm>
-            <a:off x="704088" y="1581912"/>
-            <a:ext cx="1225296" cy="265176"/>
-          </a:xfrm>
-          <a:prstGeom prst="rect">
-            <a:avLst/>
-          </a:prstGeom>
-          <a:noFill/>
-        </p:spPr>
-        <p:txBody>
-          <a:bodyPr wrap="square" lIns="0" rIns="0" tIns="0" bIns="0" anchor="ctr">
-            <a:spAutoFit/>
-          </a:bodyPr>
-          <a:lstStyle/>
-          <a:p>
-            <a:pPr algn="ctr">
-              <a:lnSpc>
-                <a:spcPct val="100000"/>
-              </a:lnSpc>
-            </a:pPr>
-            <a:r>
-              <a:rPr sz="1250" b="1" i="0">
-                <a:solidFill>
-                  <a:srgbClr val="FFFFFF"/>
-                </a:solidFill>
-                <a:latin typeface="Aptos"/>
-              </a:rPr>
-              <a:t>MAN</a:t>
-            </a:r>
-          </a:p>
-        </p:txBody>
-      </p:sp>
-      <p:sp>
-        <p:nvSpPr>
-          <p:cNvPr id="9" name="TextBox 8"/>
-          <p:cNvSpPr txBox="1"/>
-          <p:nvPr/>
-        </p:nvSpPr>
-        <p:spPr>
-          <a:xfrm>
-            <a:off x="2276856" y="1563624"/>
-            <a:ext cx="3154680" cy="329184"/>
-          </a:xfrm>
-          <a:prstGeom prst="rect">
-            <a:avLst/>
-          </a:prstGeom>
-          <a:noFill/>
-        </p:spPr>
-        <p:txBody>
-          <a:bodyPr wrap="square" lIns="0" rIns="0" tIns="0" bIns="0" anchor="ctr">
-            <a:spAutoFit/>
-          </a:bodyPr>
-          <a:lstStyle/>
-          <a:p>
-            <a:pPr algn="l">
-              <a:lnSpc>
-                <a:spcPct val="100000"/>
-              </a:lnSpc>
-            </a:pPr>
-            <a:r>
-              <a:rPr sz="1300" b="0" i="0">
-                <a:solidFill>
-                  <a:srgbClr val="182431"/>
-                </a:solidFill>
-                <a:latin typeface="Aptos"/>
-              </a:rPr>
-              <a:t>A person created in God’s image.</a:t>
-            </a:r>
-          </a:p>
-        </p:txBody>
-      </p:sp>
-      <p:sp>
-        <p:nvSpPr>
-          <p:cNvPr id="10" name="Rounded Rectangle 9"/>
-          <p:cNvSpPr/>
-          <p:nvPr/>
-        </p:nvSpPr>
-        <p:spPr>
-          <a:xfrm>
-            <a:off x="621792" y="2295144"/>
-            <a:ext cx="5138928" cy="658368"/>
-          </a:xfrm>
-          <a:prstGeom prst="roundRect">
-            <a:avLst/>
-          </a:prstGeom>
-          <a:solidFill>
-            <a:srgbClr val="DDE4E9"/>
-          </a:solidFill>
-          <a:ln>
-            <a:noFill/>
-          </a:ln>
-        </p:spPr>
-        <p:style>
-          <a:lnRef idx="1">
-            <a:schemeClr val="accent1"/>
-          </a:lnRef>
-          <a:fillRef idx="3">
-            <a:schemeClr val="accent1"/>
-          </a:fillRef>
-          <a:effectRef idx="2">
-            <a:schemeClr val="accent1"/>
-          </a:effectRef>
-          <a:fontRef idx="minor">
-            <a:schemeClr val="lt1"/>
-          </a:fontRef>
-        </p:style>
-        <p:txBody>
-          <a:bodyPr rtlCol="0" anchor="ctr"/>
-          <a:lstStyle/>
-          <a:p>
-            <a:pPr algn="ctr"/>
-          </a:p>
-        </p:txBody>
-      </p:sp>
-      <p:sp>
-        <p:nvSpPr>
-          <p:cNvPr id="11" name="Rounded Rectangle 10"/>
-          <p:cNvSpPr/>
-          <p:nvPr/>
-        </p:nvSpPr>
-        <p:spPr>
-          <a:xfrm>
-            <a:off x="576072" y="2249424"/>
-            <a:ext cx="5138928" cy="658368"/>
-          </a:xfrm>
-          <a:prstGeom prst="roundRect">
-            <a:avLst/>
-          </a:prstGeom>
-          <a:solidFill>
-            <a:srgbClr val="FFFFFF"/>
-          </a:solidFill>
-          <a:ln w="8890">
-            <a:solidFill>
-              <a:srgbClr val="E7E1D7"/>
-            </a:solidFill>
-          </a:ln>
-        </p:spPr>
-        <p:style>
-          <a:lnRef idx="1">
-            <a:schemeClr val="accent1"/>
-          </a:lnRef>
-          <a:fillRef idx="3">
-            <a:schemeClr val="accent1"/>
-          </a:fillRef>
-          <a:effectRef idx="2">
-            <a:schemeClr val="accent1"/>
-          </a:effectRef>
-          <a:fontRef idx="minor">
-            <a:schemeClr val="lt1"/>
-          </a:fontRef>
-        </p:style>
-        <p:txBody>
-          <a:bodyPr rtlCol="0" anchor="ctr"/>
-          <a:lstStyle/>
-          <a:p>
-            <a:pPr algn="ctr"/>
-          </a:p>
-        </p:txBody>
-      </p:sp>
-      <p:sp>
-        <p:nvSpPr>
-          <p:cNvPr id="12" name="Rounded Rectangle 11"/>
-          <p:cNvSpPr/>
-          <p:nvPr/>
-        </p:nvSpPr>
-        <p:spPr>
-          <a:xfrm>
-            <a:off x="576072" y="2249424"/>
-            <a:ext cx="1481328" cy="658368"/>
-          </a:xfrm>
-          <a:prstGeom prst="roundRect">
-            <a:avLst/>
-          </a:prstGeom>
-          <a:solidFill>
-            <a:srgbClr val="102D4D"/>
-          </a:solidFill>
-          <a:ln>
-            <a:noFill/>
-          </a:ln>
-        </p:spPr>
-        <p:style>
-          <a:lnRef idx="1">
-            <a:schemeClr val="accent1"/>
-          </a:lnRef>
-          <a:fillRef idx="3">
-            <a:schemeClr val="accent1"/>
-          </a:fillRef>
-          <a:effectRef idx="2">
-            <a:schemeClr val="accent1"/>
-          </a:effectRef>
-          <a:fontRef idx="minor">
-            <a:schemeClr val="lt1"/>
-          </a:fontRef>
-        </p:style>
-        <p:txBody>
-          <a:bodyPr rtlCol="0" anchor="ctr"/>
-          <a:lstStyle/>
-          <a:p>
-            <a:pPr algn="ctr"/>
-          </a:p>
-        </p:txBody>
-      </p:sp>
-      <p:sp>
-        <p:nvSpPr>
-          <p:cNvPr id="13" name="TextBox 12"/>
-          <p:cNvSpPr txBox="1"/>
-          <p:nvPr/>
-        </p:nvSpPr>
-        <p:spPr>
-          <a:xfrm>
-            <a:off x="704088" y="2414016"/>
-            <a:ext cx="1225296" cy="265176"/>
-          </a:xfrm>
-          <a:prstGeom prst="rect">
-            <a:avLst/>
-          </a:prstGeom>
-          <a:noFill/>
-        </p:spPr>
-        <p:txBody>
-          <a:bodyPr wrap="square" lIns="0" rIns="0" tIns="0" bIns="0" anchor="ctr">
-            <a:spAutoFit/>
-          </a:bodyPr>
-          <a:lstStyle/>
-          <a:p>
-            <a:pPr algn="ctr">
-              <a:lnSpc>
-                <a:spcPct val="100000"/>
-              </a:lnSpc>
-            </a:pPr>
-            <a:r>
-              <a:rPr sz="1250" b="1" i="0">
-                <a:solidFill>
-                  <a:srgbClr val="FFFFFF"/>
-                </a:solidFill>
-                <a:latin typeface="Aptos"/>
-              </a:rPr>
-              <a:t>INTO</a:t>
-            </a:r>
-          </a:p>
-        </p:txBody>
-      </p:sp>
-      <p:sp>
-        <p:nvSpPr>
-          <p:cNvPr id="14" name="TextBox 13"/>
-          <p:cNvSpPr txBox="1"/>
-          <p:nvPr/>
-        </p:nvSpPr>
-        <p:spPr>
-          <a:xfrm>
-            <a:off x="2276856" y="2395728"/>
-            <a:ext cx="3154680" cy="329184"/>
-          </a:xfrm>
-          <a:prstGeom prst="rect">
-            <a:avLst/>
-          </a:prstGeom>
-          <a:noFill/>
-        </p:spPr>
-        <p:txBody>
-          <a:bodyPr wrap="square" lIns="0" rIns="0" tIns="0" bIns="0" anchor="ctr">
-            <a:spAutoFit/>
-          </a:bodyPr>
-          <a:lstStyle/>
-          <a:p>
-            <a:pPr algn="l">
-              <a:lnSpc>
-                <a:spcPct val="100000"/>
-              </a:lnSpc>
-            </a:pPr>
-            <a:r>
-              <a:rPr sz="1300" b="0" i="0">
-                <a:solidFill>
-                  <a:srgbClr val="182431"/>
-                </a:solidFill>
-                <a:latin typeface="Aptos"/>
-              </a:rPr>
-              <a:t>A journey of becoming.</a:t>
-            </a:r>
-          </a:p>
-        </p:txBody>
-      </p:sp>
-      <p:sp>
-        <p:nvSpPr>
-          <p:cNvPr id="15" name="Rounded Rectangle 14"/>
-          <p:cNvSpPr/>
-          <p:nvPr/>
-        </p:nvSpPr>
-        <p:spPr>
-          <a:xfrm>
-            <a:off x="621792" y="3127248"/>
-            <a:ext cx="5138928" cy="658368"/>
-          </a:xfrm>
-          <a:prstGeom prst="roundRect">
-            <a:avLst/>
-          </a:prstGeom>
-          <a:solidFill>
-            <a:srgbClr val="DDE4E9"/>
-          </a:solidFill>
-          <a:ln>
-            <a:noFill/>
-          </a:ln>
-        </p:spPr>
-        <p:style>
-          <a:lnRef idx="1">
-            <a:schemeClr val="accent1"/>
-          </a:lnRef>
-          <a:fillRef idx="3">
-            <a:schemeClr val="accent1"/>
-          </a:fillRef>
-          <a:effectRef idx="2">
-            <a:schemeClr val="accent1"/>
-          </a:effectRef>
-          <a:fontRef idx="minor">
-            <a:schemeClr val="lt1"/>
-          </a:fontRef>
-        </p:style>
-        <p:txBody>
-          <a:bodyPr rtlCol="0" anchor="ctr"/>
-          <a:lstStyle/>
-          <a:p>
-            <a:pPr algn="ctr"/>
-          </a:p>
-        </p:txBody>
-      </p:sp>
-      <p:sp>
-        <p:nvSpPr>
-          <p:cNvPr id="16" name="Rounded Rectangle 15"/>
-          <p:cNvSpPr/>
-          <p:nvPr/>
-        </p:nvSpPr>
-        <p:spPr>
-          <a:xfrm>
-            <a:off x="576072" y="3081528"/>
-            <a:ext cx="5138928" cy="658368"/>
-          </a:xfrm>
-          <a:prstGeom prst="roundRect">
-            <a:avLst/>
-          </a:prstGeom>
-          <a:solidFill>
-            <a:srgbClr val="FFFFFF"/>
-          </a:solidFill>
-          <a:ln w="8890">
-            <a:solidFill>
-              <a:srgbClr val="E7E1D7"/>
-            </a:solidFill>
-          </a:ln>
-        </p:spPr>
-        <p:style>
-          <a:lnRef idx="1">
-            <a:schemeClr val="accent1"/>
-          </a:lnRef>
-          <a:fillRef idx="3">
-            <a:schemeClr val="accent1"/>
-          </a:fillRef>
-          <a:effectRef idx="2">
-            <a:schemeClr val="accent1"/>
-          </a:effectRef>
-          <a:fontRef idx="minor">
-            <a:schemeClr val="lt1"/>
-          </a:fontRef>
-        </p:style>
-        <p:txBody>
-          <a:bodyPr rtlCol="0" anchor="ctr"/>
-          <a:lstStyle/>
-          <a:p>
-            <a:pPr algn="ctr"/>
-          </a:p>
-        </p:txBody>
-      </p:sp>
-      <p:sp>
-        <p:nvSpPr>
-          <p:cNvPr id="17" name="Rounded Rectangle 16"/>
-          <p:cNvSpPr/>
-          <p:nvPr/>
-        </p:nvSpPr>
-        <p:spPr>
-          <a:xfrm>
-            <a:off x="576072" y="3081528"/>
-            <a:ext cx="1481328" cy="658368"/>
-          </a:xfrm>
-          <a:prstGeom prst="roundRect">
-            <a:avLst/>
-          </a:prstGeom>
-          <a:solidFill>
-            <a:srgbClr val="102D4D"/>
-          </a:solidFill>
-          <a:ln>
-            <a:noFill/>
-          </a:ln>
-        </p:spPr>
-        <p:style>
-          <a:lnRef idx="1">
-            <a:schemeClr val="accent1"/>
-          </a:lnRef>
-          <a:fillRef idx="3">
-            <a:schemeClr val="accent1"/>
-          </a:fillRef>
-          <a:effectRef idx="2">
-            <a:schemeClr val="accent1"/>
-          </a:effectRef>
-          <a:fontRef idx="minor">
-            <a:schemeClr val="lt1"/>
-          </a:fontRef>
-        </p:style>
-        <p:txBody>
-          <a:bodyPr rtlCol="0" anchor="ctr"/>
-          <a:lstStyle/>
-          <a:p>
-            <a:pPr algn="ctr"/>
-          </a:p>
-        </p:txBody>
-      </p:sp>
-      <p:sp>
-        <p:nvSpPr>
-          <p:cNvPr id="18" name="TextBox 17"/>
-          <p:cNvSpPr txBox="1"/>
-          <p:nvPr/>
-        </p:nvSpPr>
-        <p:spPr>
-          <a:xfrm>
-            <a:off x="704088" y="3246120"/>
-            <a:ext cx="1225296" cy="265176"/>
-          </a:xfrm>
-          <a:prstGeom prst="rect">
-            <a:avLst/>
-          </a:prstGeom>
-          <a:noFill/>
-        </p:spPr>
-        <p:txBody>
-          <a:bodyPr wrap="square" lIns="0" rIns="0" tIns="0" bIns="0" anchor="ctr">
-            <a:spAutoFit/>
-          </a:bodyPr>
-          <a:lstStyle/>
-          <a:p>
-            <a:pPr algn="ctr">
-              <a:lnSpc>
-                <a:spcPct val="100000"/>
-              </a:lnSpc>
-            </a:pPr>
-            <a:r>
-              <a:rPr sz="1250" b="1" i="0">
-                <a:solidFill>
-                  <a:srgbClr val="FFFFFF"/>
-                </a:solidFill>
-                <a:latin typeface="Aptos"/>
-              </a:rPr>
-              <a:t>THE FULLEST</a:t>
-            </a:r>
-          </a:p>
-        </p:txBody>
-      </p:sp>
-      <p:sp>
-        <p:nvSpPr>
-          <p:cNvPr id="19" name="TextBox 18"/>
-          <p:cNvSpPr txBox="1"/>
-          <p:nvPr/>
-        </p:nvSpPr>
-        <p:spPr>
-          <a:xfrm>
-            <a:off x="2276856" y="3227832"/>
-            <a:ext cx="3154680" cy="329184"/>
-          </a:xfrm>
-          <a:prstGeom prst="rect">
-            <a:avLst/>
-          </a:prstGeom>
-          <a:noFill/>
-        </p:spPr>
-        <p:txBody>
-          <a:bodyPr wrap="square" lIns="0" rIns="0" tIns="0" bIns="0" anchor="ctr">
-            <a:spAutoFit/>
-          </a:bodyPr>
-          <a:lstStyle/>
-          <a:p>
-            <a:pPr algn="l">
-              <a:lnSpc>
-                <a:spcPct val="100000"/>
-              </a:lnSpc>
-            </a:pPr>
-            <a:r>
-              <a:rPr sz="1300" b="0" i="0">
-                <a:solidFill>
-                  <a:srgbClr val="182431"/>
-                </a:solidFill>
-                <a:latin typeface="Aptos"/>
-              </a:rPr>
-              <a:t>Growing toward the fullness of God’s purpose.</a:t>
-            </a:r>
-          </a:p>
-        </p:txBody>
-      </p:sp>
-      <p:sp>
-        <p:nvSpPr>
-          <p:cNvPr id="20" name="Rounded Rectangle 19"/>
-          <p:cNvSpPr/>
-          <p:nvPr/>
-        </p:nvSpPr>
-        <p:spPr>
-          <a:xfrm>
-            <a:off x="621792" y="3959352"/>
-            <a:ext cx="5138928" cy="658368"/>
-          </a:xfrm>
-          <a:prstGeom prst="roundRect">
-            <a:avLst/>
-          </a:prstGeom>
-          <a:solidFill>
-            <a:srgbClr val="DDE4E9"/>
-          </a:solidFill>
-          <a:ln>
-            <a:noFill/>
-          </a:ln>
-        </p:spPr>
-        <p:style>
-          <a:lnRef idx="1">
-            <a:schemeClr val="accent1"/>
-          </a:lnRef>
-          <a:fillRef idx="3">
-            <a:schemeClr val="accent1"/>
-          </a:fillRef>
-          <a:effectRef idx="2">
-            <a:schemeClr val="accent1"/>
-          </a:effectRef>
-          <a:fontRef idx="minor">
-            <a:schemeClr val="lt1"/>
-          </a:fontRef>
-        </p:style>
-        <p:txBody>
-          <a:bodyPr rtlCol="0" anchor="ctr"/>
-          <a:lstStyle/>
-          <a:p>
-            <a:pPr algn="ctr"/>
-          </a:p>
-        </p:txBody>
-      </p:sp>
-      <p:sp>
-        <p:nvSpPr>
-          <p:cNvPr id="21" name="Rounded Rectangle 20"/>
-          <p:cNvSpPr/>
-          <p:nvPr/>
-        </p:nvSpPr>
-        <p:spPr>
-          <a:xfrm>
-            <a:off x="576072" y="3913632"/>
-            <a:ext cx="5138928" cy="658368"/>
-          </a:xfrm>
-          <a:prstGeom prst="roundRect">
-            <a:avLst/>
-          </a:prstGeom>
-          <a:solidFill>
-            <a:srgbClr val="FFFFFF"/>
-          </a:solidFill>
-          <a:ln w="8890">
-            <a:solidFill>
-              <a:srgbClr val="E7E1D7"/>
-            </a:solidFill>
-          </a:ln>
-        </p:spPr>
-        <p:style>
-          <a:lnRef idx="1">
-            <a:schemeClr val="accent1"/>
-          </a:lnRef>
-          <a:fillRef idx="3">
-            <a:schemeClr val="accent1"/>
-          </a:fillRef>
-          <a:effectRef idx="2">
-            <a:schemeClr val="accent1"/>
-          </a:effectRef>
-          <a:fontRef idx="minor">
-            <a:schemeClr val="lt1"/>
-          </a:fontRef>
-        </p:style>
-        <p:txBody>
-          <a:bodyPr rtlCol="0" anchor="ctr"/>
-          <a:lstStyle/>
-          <a:p>
-            <a:pPr algn="ctr"/>
-          </a:p>
-        </p:txBody>
-      </p:sp>
-      <p:sp>
-        <p:nvSpPr>
-          <p:cNvPr id="22" name="Rounded Rectangle 21"/>
-          <p:cNvSpPr/>
-          <p:nvPr/>
-        </p:nvSpPr>
-        <p:spPr>
-          <a:xfrm>
-            <a:off x="576072" y="3913632"/>
-            <a:ext cx="1481328" cy="658368"/>
-          </a:xfrm>
-          <a:prstGeom prst="roundRect">
-            <a:avLst/>
-          </a:prstGeom>
-          <a:solidFill>
-            <a:srgbClr val="102D4D"/>
-          </a:solidFill>
-          <a:ln>
-            <a:noFill/>
-          </a:ln>
-        </p:spPr>
-        <p:style>
-          <a:lnRef idx="1">
-            <a:schemeClr val="accent1"/>
-          </a:lnRef>
-          <a:fillRef idx="3">
-            <a:schemeClr val="accent1"/>
-          </a:fillRef>
-          <a:effectRef idx="2">
-            <a:schemeClr val="accent1"/>
-          </a:effectRef>
-          <a:fontRef idx="minor">
-            <a:schemeClr val="lt1"/>
-          </a:fontRef>
-        </p:style>
-        <p:txBody>
-          <a:bodyPr rtlCol="0" anchor="ctr"/>
-          <a:lstStyle/>
-          <a:p>
-            <a:pPr algn="ctr"/>
-          </a:p>
-        </p:txBody>
-      </p:sp>
-      <p:sp>
-        <p:nvSpPr>
-          <p:cNvPr id="23" name="TextBox 22"/>
-          <p:cNvSpPr txBox="1"/>
-          <p:nvPr/>
-        </p:nvSpPr>
-        <p:spPr>
-          <a:xfrm>
-            <a:off x="704088" y="4078224"/>
-            <a:ext cx="1225296" cy="265176"/>
-          </a:xfrm>
-          <a:prstGeom prst="rect">
-            <a:avLst/>
-          </a:prstGeom>
-          <a:noFill/>
-        </p:spPr>
-        <p:txBody>
-          <a:bodyPr wrap="square" lIns="0" rIns="0" tIns="0" bIns="0" anchor="ctr">
-            <a:spAutoFit/>
-          </a:bodyPr>
-          <a:lstStyle/>
-          <a:p>
-            <a:pPr algn="ctr">
-              <a:lnSpc>
-                <a:spcPct val="100000"/>
-              </a:lnSpc>
-            </a:pPr>
-            <a:r>
-              <a:rPr sz="1250" b="1" i="0">
-                <a:solidFill>
-                  <a:srgbClr val="FFFFFF"/>
-                </a:solidFill>
-                <a:latin typeface="Aptos"/>
-              </a:rPr>
-              <a:t>ESTEEM</a:t>
-            </a:r>
-          </a:p>
-        </p:txBody>
-      </p:sp>
-      <p:sp>
-        <p:nvSpPr>
-          <p:cNvPr id="24" name="TextBox 23"/>
-          <p:cNvSpPr txBox="1"/>
-          <p:nvPr/>
-        </p:nvSpPr>
-        <p:spPr>
-          <a:xfrm>
-            <a:off x="2276856" y="4059936"/>
-            <a:ext cx="3154680" cy="329184"/>
-          </a:xfrm>
-          <a:prstGeom prst="rect">
-            <a:avLst/>
-          </a:prstGeom>
-          <a:noFill/>
-        </p:spPr>
-        <p:txBody>
-          <a:bodyPr wrap="square" lIns="0" rIns="0" tIns="0" bIns="0" anchor="ctr">
-            <a:spAutoFit/>
-          </a:bodyPr>
-          <a:lstStyle/>
-          <a:p>
-            <a:pPr algn="l">
-              <a:lnSpc>
-                <a:spcPct val="100000"/>
-              </a:lnSpc>
-            </a:pPr>
-            <a:r>
-              <a:rPr sz="1300" b="0" i="0">
-                <a:solidFill>
-                  <a:srgbClr val="182431"/>
-                </a:solidFill>
-                <a:latin typeface="Aptos"/>
-              </a:rPr>
-              <a:t>Knowing our God-given value and dignity.</a:t>
-            </a:r>
-          </a:p>
-        </p:txBody>
-      </p:sp>
-      <p:sp>
-        <p:nvSpPr>
-          <p:cNvPr id="25" name="Rounded Rectangle 24"/>
-          <p:cNvSpPr/>
-          <p:nvPr/>
-        </p:nvSpPr>
-        <p:spPr>
-          <a:xfrm>
-            <a:off x="576072" y="4956048"/>
-            <a:ext cx="5138928" cy="960120"/>
-          </a:xfrm>
-          <a:prstGeom prst="roundRect">
+            <a:off x="4581144" y="950976"/>
+            <a:ext cx="475488" cy="41148"/>
+          </a:xfrm>
+          <a:prstGeom prst="rect">
             <a:avLst/>
           </a:prstGeom>
           <a:solidFill>
@@ -10426,14 +10074,14 @@
       </p:sp>
       <p:sp>
         <p:nvSpPr>
-          <p:cNvPr id="26" name="TextBox 25"/>
+          <p:cNvPr id="16" name="TextBox 15"/>
           <p:cNvSpPr txBox="1"/>
           <p:nvPr/>
         </p:nvSpPr>
         <p:spPr>
           <a:xfrm>
-            <a:off x="822960" y="5175504"/>
-            <a:ext cx="1234440" cy="219456"/>
+            <a:off x="4581144" y="1133856"/>
+            <a:ext cx="2487168" cy="219456"/>
           </a:xfrm>
           <a:prstGeom prst="rect">
             <a:avLst/>
@@ -10447,32 +10095,35 @@
           <a:lstStyle/>
           <a:p>
             <a:pPr algn="l">
-              <a:lnSpc>
-                <a:spcPct val="100000"/>
-              </a:lnSpc>
-            </a:pPr>
-            <a:r>
-              <a:rPr sz="1000" b="1" i="0">
-                <a:solidFill>
-                  <a:srgbClr val="071A2D"/>
+              <a:spcBef>
+                <a:spcPts val="0"/>
+              </a:spcBef>
+              <a:spcAft>
+                <a:spcPts val="0"/>
+              </a:spcAft>
+            </a:pPr>
+            <a:r>
+              <a:rPr sz="1050" b="1" i="0">
+                <a:solidFill>
+                  <a:srgbClr val="102D4D"/>
                 </a:solidFill>
                 <a:latin typeface="Aptos"/>
               </a:rPr>
-              <a:t>MANIFEST</a:t>
-            </a:r>
-          </a:p>
-        </p:txBody>
-      </p:sp>
-      <p:sp>
-        <p:nvSpPr>
-          <p:cNvPr id="27" name="TextBox 26"/>
+              <a:t>MAN</a:t>
+            </a:r>
+          </a:p>
+        </p:txBody>
+      </p:sp>
+      <p:sp>
+        <p:nvSpPr>
+          <p:cNvPr id="17" name="TextBox 16"/>
           <p:cNvSpPr txBox="1"/>
           <p:nvPr/>
         </p:nvSpPr>
         <p:spPr>
           <a:xfrm>
-            <a:off x="1993392" y="5074920"/>
-            <a:ext cx="3429000" cy="548640"/>
+            <a:off x="7114031" y="1115568"/>
+            <a:ext cx="384048" cy="228600"/>
           </a:xfrm>
           <a:prstGeom prst="rect">
             <a:avLst/>
@@ -10485,67 +10136,103 @@
           </a:bodyPr>
           <a:lstStyle/>
           <a:p>
-            <a:pPr algn="l">
+            <a:pPr algn="r">
+              <a:spcBef>
+                <a:spcPts val="0"/>
+              </a:spcBef>
+              <a:spcAft>
+                <a:spcPts val="0"/>
+              </a:spcAft>
+            </a:pPr>
+            <a:r>
+              <a:rPr sz="900" b="1" i="0">
+                <a:solidFill>
+                  <a:srgbClr val="D7A13A"/>
+                </a:solidFill>
+                <a:latin typeface="Aptos"/>
+              </a:rPr>
+              <a:t>01</a:t>
+            </a:r>
+          </a:p>
+        </p:txBody>
+      </p:sp>
+      <p:sp>
+        <p:nvSpPr>
+          <p:cNvPr id="18" name="TextBox 17"/>
+          <p:cNvSpPr txBox="1"/>
+          <p:nvPr/>
+        </p:nvSpPr>
+        <p:spPr>
+          <a:xfrm>
+            <a:off x="4581144" y="1481328"/>
+            <a:ext cx="2907792" cy="548640"/>
+          </a:xfrm>
+          <a:prstGeom prst="rect">
+            <a:avLst/>
+          </a:prstGeom>
+          <a:noFill/>
+        </p:spPr>
+        <p:txBody>
+          <a:bodyPr wrap="square" lIns="0" rIns="0" tIns="0" bIns="0">
+            <a:spAutoFit/>
+          </a:bodyPr>
+          <a:lstStyle/>
+          <a:p>
+            <a:pPr>
               <a:lnSpc>
                 <a:spcPct val="105000"/>
               </a:lnSpc>
-            </a:pPr>
-            <a:r>
-              <a:rPr sz="1230" b="1" i="0">
-                <a:solidFill>
-                  <a:srgbClr val="071A2D"/>
+              <a:spcBef>
+                <a:spcPts val="0"/>
+              </a:spcBef>
+              <a:spcAft>
+                <a:spcPts val="0"/>
+              </a:spcAft>
+            </a:pPr>
+            <a:r>
+              <a:rPr sz="1400">
+                <a:solidFill>
+                  <a:srgbClr val="627080"/>
                 </a:solidFill>
                 <a:latin typeface="Aptos"/>
               </a:rPr>
-              <a:t>People becoming who God created them to be through the transforming power of the Gospel.</a:t>
-            </a:r>
-          </a:p>
-        </p:txBody>
-      </p:sp>
-      <p:pic>
-        <p:nvPicPr>
-          <p:cNvPr id="28" name="Picture 27" descr="identity-01.jpg"/>
-          <p:cNvPicPr>
-            <a:picLocks noChangeAspect="1"/>
-          </p:cNvPicPr>
-          <p:nvPr/>
-        </p:nvPicPr>
-        <p:blipFill>
-          <a:blip r:embed="rId2"/>
-          <a:srcRect l="8372" r="8372"/>
-          <a:stretch>
-            <a:fillRect/>
-          </a:stretch>
-        </p:blipFill>
-        <p:spPr>
-          <a:xfrm>
-            <a:off x="6035040" y="1280160"/>
-            <a:ext cx="5532120" cy="4983480"/>
-          </a:xfrm>
-          <a:prstGeom prst="rect">
-            <a:avLst/>
-          </a:prstGeom>
-        </p:spPr>
-      </p:pic>
-      <p:sp>
-        <p:nvSpPr>
-          <p:cNvPr id="29" name="Rounded Rectangle 28"/>
+              <a:t>A person created in </a:t>
+            </a:r>
+            <a:r>
+              <a:rPr sz="1400" b="1">
+                <a:solidFill>
+                  <a:srgbClr val="102D4D"/>
+                </a:solidFill>
+                <a:latin typeface="Aptos"/>
+              </a:rPr>
+              <a:t>God’s image.</a:t>
+            </a:r>
+          </a:p>
+        </p:txBody>
+      </p:sp>
+      <p:sp>
+        <p:nvSpPr>
+          <p:cNvPr id="19" name="Rounded Rectangle 18"/>
           <p:cNvSpPr/>
           <p:nvPr/>
         </p:nvSpPr>
         <p:spPr>
           <a:xfrm>
-            <a:off x="6291072" y="5175504"/>
-            <a:ext cx="5001768" cy="713232"/>
+            <a:off x="7982712" y="950976"/>
+            <a:ext cx="3383280" cy="1325880"/>
           </a:xfrm>
           <a:prstGeom prst="roundRect">
-            <a:avLst/>
+            <a:avLst>
+              <a:gd name="adj" fmla="val 8000"/>
+            </a:avLst>
           </a:prstGeom>
           <a:solidFill>
-            <a:srgbClr val="071A2D"/>
+            <a:srgbClr val="F7F4EE"/>
           </a:solidFill>
-          <a:ln>
-            <a:noFill/>
+          <a:ln w="10160">
+            <a:solidFill>
+              <a:srgbClr val="E4DCCE"/>
+            </a:solidFill>
           </a:ln>
         </p:spPr>
         <p:style>
@@ -10572,14 +10259,57 @@
       </p:sp>
       <p:sp>
         <p:nvSpPr>
-          <p:cNvPr id="30" name="TextBox 29"/>
+          <p:cNvPr id="20" name="Rectangle 19"/>
+          <p:cNvSpPr/>
+          <p:nvPr/>
+        </p:nvSpPr>
+        <p:spPr>
+          <a:xfrm>
+            <a:off x="8211312" y="950976"/>
+            <a:ext cx="475488" cy="41148"/>
+          </a:xfrm>
+          <a:prstGeom prst="rect">
+            <a:avLst/>
+          </a:prstGeom>
+          <a:solidFill>
+            <a:srgbClr val="D7A13A"/>
+          </a:solidFill>
+          <a:ln>
+            <a:noFill/>
+          </a:ln>
+        </p:spPr>
+        <p:style>
+          <a:lnRef idx="1">
+            <a:schemeClr val="accent1"/>
+          </a:lnRef>
+          <a:fillRef idx="3">
+            <a:schemeClr val="accent1"/>
+          </a:fillRef>
+          <a:effectRef idx="2">
+            <a:schemeClr val="accent1"/>
+          </a:effectRef>
+          <a:fontRef idx="minor">
+            <a:schemeClr val="lt1"/>
+          </a:fontRef>
+        </p:style>
+        <p:txBody>
+          <a:bodyPr rtlCol="0" anchor="ctr"/>
+          <a:lstStyle/>
+          <a:p>
+            <a:pPr algn="ctr"/>
+          </a:p>
+        </p:txBody>
+      </p:sp>
+      <p:sp>
+        <p:nvSpPr>
+          <p:cNvPr id="21" name="TextBox 20"/>
           <p:cNvSpPr txBox="1"/>
           <p:nvPr/>
         </p:nvSpPr>
         <p:spPr>
           <a:xfrm>
-            <a:off x="6565392" y="5394960"/>
-            <a:ext cx="4443984" cy="219456"/>
+            <a:off x="8211312" y="1133856"/>
+            <a:ext cx="2487168" cy="219456"/>
           </a:xfrm>
           <a:prstGeom prst="rect">
             <a:avLst/>
@@ -10592,20 +10322,437 @@
           </a:bodyPr>
           <a:lstStyle/>
           <a:p>
-            <a:pPr algn="ctr">
+            <a:pPr algn="l">
+              <a:spcBef>
+                <a:spcPts val="0"/>
+              </a:spcBef>
+              <a:spcAft>
+                <a:spcPts val="0"/>
+              </a:spcAft>
+            </a:pPr>
+            <a:r>
+              <a:rPr sz="1050" b="1" i="0">
+                <a:solidFill>
+                  <a:srgbClr val="102D4D"/>
+                </a:solidFill>
+                <a:latin typeface="Aptos"/>
+              </a:rPr>
+              <a:t>INTO</a:t>
+            </a:r>
+          </a:p>
+        </p:txBody>
+      </p:sp>
+      <p:sp>
+        <p:nvSpPr>
+          <p:cNvPr id="22" name="TextBox 21"/>
+          <p:cNvSpPr txBox="1"/>
+          <p:nvPr/>
+        </p:nvSpPr>
+        <p:spPr>
+          <a:xfrm>
+            <a:off x="10744200" y="1115568"/>
+            <a:ext cx="384048" cy="228600"/>
+          </a:xfrm>
+          <a:prstGeom prst="rect">
+            <a:avLst/>
+          </a:prstGeom>
+          <a:noFill/>
+        </p:spPr>
+        <p:txBody>
+          <a:bodyPr wrap="square" lIns="0" rIns="0" tIns="0" bIns="0" anchor="t">
+            <a:spAutoFit/>
+          </a:bodyPr>
+          <a:lstStyle/>
+          <a:p>
+            <a:pPr algn="r">
+              <a:spcBef>
+                <a:spcPts val="0"/>
+              </a:spcBef>
+              <a:spcAft>
+                <a:spcPts val="0"/>
+              </a:spcAft>
+            </a:pPr>
+            <a:r>
+              <a:rPr sz="900" b="1" i="0">
+                <a:solidFill>
+                  <a:srgbClr val="D7A13A"/>
+                </a:solidFill>
+                <a:latin typeface="Aptos"/>
+              </a:rPr>
+              <a:t>02</a:t>
+            </a:r>
+          </a:p>
+        </p:txBody>
+      </p:sp>
+      <p:sp>
+        <p:nvSpPr>
+          <p:cNvPr id="23" name="TextBox 22"/>
+          <p:cNvSpPr txBox="1"/>
+          <p:nvPr/>
+        </p:nvSpPr>
+        <p:spPr>
+          <a:xfrm>
+            <a:off x="8211312" y="1481328"/>
+            <a:ext cx="2907792" cy="548640"/>
+          </a:xfrm>
+          <a:prstGeom prst="rect">
+            <a:avLst/>
+          </a:prstGeom>
+          <a:noFill/>
+        </p:spPr>
+        <p:txBody>
+          <a:bodyPr wrap="square" lIns="0" rIns="0" tIns="0" bIns="0">
+            <a:spAutoFit/>
+          </a:bodyPr>
+          <a:lstStyle/>
+          <a:p>
+            <a:pPr>
               <a:lnSpc>
-                <a:spcPct val="100000"/>
+                <a:spcPct val="105000"/>
               </a:lnSpc>
-            </a:pPr>
-            <a:r>
-              <a:rPr sz="1400" b="1" i="0">
-                <a:solidFill>
-                  <a:srgbClr val="F0CC7A"/>
-                </a:solidFill>
-                <a:latin typeface="Aptos Display"/>
-              </a:rPr>
-              <a:t>Identity. Purpose. Dignity.</a:t>
-            </a:r>
+              <a:spcBef>
+                <a:spcPts val="0"/>
+              </a:spcBef>
+              <a:spcAft>
+                <a:spcPts val="0"/>
+              </a:spcAft>
+            </a:pPr>
+            <a:r>
+              <a:rPr sz="1400">
+                <a:solidFill>
+                  <a:srgbClr val="627080"/>
+                </a:solidFill>
+                <a:latin typeface="Aptos"/>
+              </a:rPr>
+              <a:t>A journey of </a:t>
+            </a:r>
+            <a:r>
+              <a:rPr sz="1400" b="1">
+                <a:solidFill>
+                  <a:srgbClr val="102D4D"/>
+                </a:solidFill>
+                <a:latin typeface="Aptos"/>
+              </a:rPr>
+              <a:t>becoming.</a:t>
+            </a:r>
+          </a:p>
+        </p:txBody>
+      </p:sp>
+      <p:sp>
+        <p:nvSpPr>
+          <p:cNvPr id="24" name="Rounded Rectangle 23"/>
+          <p:cNvSpPr/>
+          <p:nvPr/>
+        </p:nvSpPr>
+        <p:spPr>
+          <a:xfrm>
+            <a:off x="4352544" y="2487168"/>
+            <a:ext cx="3383280" cy="1325880"/>
+          </a:xfrm>
+          <a:prstGeom prst="roundRect">
+            <a:avLst>
+              <a:gd name="adj" fmla="val 8000"/>
+            </a:avLst>
+          </a:prstGeom>
+          <a:solidFill>
+            <a:srgbClr val="F7F4EE"/>
+          </a:solidFill>
+          <a:ln w="10160">
+            <a:solidFill>
+              <a:srgbClr val="E4DCCE"/>
+            </a:solidFill>
+          </a:ln>
+        </p:spPr>
+        <p:style>
+          <a:lnRef idx="1">
+            <a:schemeClr val="accent1"/>
+          </a:lnRef>
+          <a:fillRef idx="3">
+            <a:schemeClr val="accent1"/>
+          </a:fillRef>
+          <a:effectRef idx="2">
+            <a:schemeClr val="accent1"/>
+          </a:effectRef>
+          <a:fontRef idx="minor">
+            <a:schemeClr val="lt1"/>
+          </a:fontRef>
+        </p:style>
+        <p:txBody>
+          <a:bodyPr rtlCol="0" anchor="ctr"/>
+          <a:lstStyle/>
+          <a:p>
+            <a:pPr algn="ctr"/>
+          </a:p>
+        </p:txBody>
+      </p:sp>
+      <p:sp>
+        <p:nvSpPr>
+          <p:cNvPr id="25" name="Rectangle 24"/>
+          <p:cNvSpPr/>
+          <p:nvPr/>
+        </p:nvSpPr>
+        <p:spPr>
+          <a:xfrm>
+            <a:off x="4581144" y="2487168"/>
+            <a:ext cx="475488" cy="41148"/>
+          </a:xfrm>
+          <a:prstGeom prst="rect">
+            <a:avLst/>
+          </a:prstGeom>
+          <a:solidFill>
+            <a:srgbClr val="D7A13A"/>
+          </a:solidFill>
+          <a:ln>
+            <a:noFill/>
+          </a:ln>
+        </p:spPr>
+        <p:style>
+          <a:lnRef idx="1">
+            <a:schemeClr val="accent1"/>
+          </a:lnRef>
+          <a:fillRef idx="3">
+            <a:schemeClr val="accent1"/>
+          </a:fillRef>
+          <a:effectRef idx="2">
+            <a:schemeClr val="accent1"/>
+          </a:effectRef>
+          <a:fontRef idx="minor">
+            <a:schemeClr val="lt1"/>
+          </a:fontRef>
+        </p:style>
+        <p:txBody>
+          <a:bodyPr rtlCol="0" anchor="ctr"/>
+          <a:lstStyle/>
+          <a:p>
+            <a:pPr algn="ctr"/>
+          </a:p>
+        </p:txBody>
+      </p:sp>
+      <p:sp>
+        <p:nvSpPr>
+          <p:cNvPr id="26" name="TextBox 25"/>
+          <p:cNvSpPr txBox="1"/>
+          <p:nvPr/>
+        </p:nvSpPr>
+        <p:spPr>
+          <a:xfrm>
+            <a:off x="4581144" y="2670048"/>
+            <a:ext cx="2487168" cy="219456"/>
+          </a:xfrm>
+          <a:prstGeom prst="rect">
+            <a:avLst/>
+          </a:prstGeom>
+          <a:noFill/>
+        </p:spPr>
+        <p:txBody>
+          <a:bodyPr wrap="square" lIns="0" rIns="0" tIns="0" bIns="0" anchor="t">
+            <a:spAutoFit/>
+          </a:bodyPr>
+          <a:lstStyle/>
+          <a:p>
+            <a:pPr algn="l">
+              <a:spcBef>
+                <a:spcPts val="0"/>
+              </a:spcBef>
+              <a:spcAft>
+                <a:spcPts val="0"/>
+              </a:spcAft>
+            </a:pPr>
+            <a:r>
+              <a:rPr sz="1050" b="1" i="0">
+                <a:solidFill>
+                  <a:srgbClr val="102D4D"/>
+                </a:solidFill>
+                <a:latin typeface="Aptos"/>
+              </a:rPr>
+              <a:t>THE FULLEST</a:t>
+            </a:r>
+          </a:p>
+        </p:txBody>
+      </p:sp>
+      <p:sp>
+        <p:nvSpPr>
+          <p:cNvPr id="27" name="TextBox 26"/>
+          <p:cNvSpPr txBox="1"/>
+          <p:nvPr/>
+        </p:nvSpPr>
+        <p:spPr>
+          <a:xfrm>
+            <a:off x="7114031" y="2651760"/>
+            <a:ext cx="384048" cy="228600"/>
+          </a:xfrm>
+          <a:prstGeom prst="rect">
+            <a:avLst/>
+          </a:prstGeom>
+          <a:noFill/>
+        </p:spPr>
+        <p:txBody>
+          <a:bodyPr wrap="square" lIns="0" rIns="0" tIns="0" bIns="0" anchor="t">
+            <a:spAutoFit/>
+          </a:bodyPr>
+          <a:lstStyle/>
+          <a:p>
+            <a:pPr algn="r">
+              <a:spcBef>
+                <a:spcPts val="0"/>
+              </a:spcBef>
+              <a:spcAft>
+                <a:spcPts val="0"/>
+              </a:spcAft>
+            </a:pPr>
+            <a:r>
+              <a:rPr sz="900" b="1" i="0">
+                <a:solidFill>
+                  <a:srgbClr val="D7A13A"/>
+                </a:solidFill>
+                <a:latin typeface="Aptos"/>
+              </a:rPr>
+              <a:t>03</a:t>
+            </a:r>
+          </a:p>
+        </p:txBody>
+      </p:sp>
+      <p:sp>
+        <p:nvSpPr>
+          <p:cNvPr id="28" name="TextBox 27"/>
+          <p:cNvSpPr txBox="1"/>
+          <p:nvPr/>
+        </p:nvSpPr>
+        <p:spPr>
+          <a:xfrm>
+            <a:off x="4581144" y="3017520"/>
+            <a:ext cx="2907792" cy="548640"/>
+          </a:xfrm>
+          <a:prstGeom prst="rect">
+            <a:avLst/>
+          </a:prstGeom>
+          <a:noFill/>
+        </p:spPr>
+        <p:txBody>
+          <a:bodyPr wrap="square" lIns="0" rIns="0" tIns="0" bIns="0">
+            <a:spAutoFit/>
+          </a:bodyPr>
+          <a:lstStyle/>
+          <a:p>
+            <a:pPr>
+              <a:lnSpc>
+                <a:spcPct val="105000"/>
+              </a:lnSpc>
+              <a:spcBef>
+                <a:spcPts val="0"/>
+              </a:spcBef>
+              <a:spcAft>
+                <a:spcPts val="0"/>
+              </a:spcAft>
+            </a:pPr>
+            <a:r>
+              <a:rPr sz="1400">
+                <a:solidFill>
+                  <a:srgbClr val="627080"/>
+                </a:solidFill>
+                <a:latin typeface="Aptos"/>
+              </a:rPr>
+              <a:t>Growing toward the fullness of </a:t>
+            </a:r>
+            <a:r>
+              <a:rPr sz="1400" b="1">
+                <a:solidFill>
+                  <a:srgbClr val="102D4D"/>
+                </a:solidFill>
+                <a:latin typeface="Aptos"/>
+              </a:rPr>
+              <a:t>God’s purpose.</a:t>
+            </a:r>
+          </a:p>
+        </p:txBody>
+      </p:sp>
+      <p:sp>
+        <p:nvSpPr>
+          <p:cNvPr id="29" name="Rounded Rectangle 28"/>
+          <p:cNvSpPr/>
+          <p:nvPr/>
+        </p:nvSpPr>
+        <p:spPr>
+          <a:xfrm>
+            <a:off x="7982712" y="2487168"/>
+            <a:ext cx="3383280" cy="1325880"/>
+          </a:xfrm>
+          <a:prstGeom prst="roundRect">
+            <a:avLst>
+              <a:gd name="adj" fmla="val 8000"/>
+            </a:avLst>
+          </a:prstGeom>
+          <a:solidFill>
+            <a:srgbClr val="F7F4EE"/>
+          </a:solidFill>
+          <a:ln w="10160">
+            <a:solidFill>
+              <a:srgbClr val="E4DCCE"/>
+            </a:solidFill>
+          </a:ln>
+        </p:spPr>
+        <p:style>
+          <a:lnRef idx="1">
+            <a:schemeClr val="accent1"/>
+          </a:lnRef>
+          <a:fillRef idx="3">
+            <a:schemeClr val="accent1"/>
+          </a:fillRef>
+          <a:effectRef idx="2">
+            <a:schemeClr val="accent1"/>
+          </a:effectRef>
+          <a:fontRef idx="minor">
+            <a:schemeClr val="lt1"/>
+          </a:fontRef>
+        </p:style>
+        <p:txBody>
+          <a:bodyPr rtlCol="0" anchor="ctr"/>
+          <a:lstStyle/>
+          <a:p>
+            <a:pPr algn="ctr"/>
+          </a:p>
+        </p:txBody>
+      </p:sp>
+      <p:sp>
+        <p:nvSpPr>
+          <p:cNvPr id="30" name="Rectangle 29"/>
+          <p:cNvSpPr/>
+          <p:nvPr/>
+        </p:nvSpPr>
+        <p:spPr>
+          <a:xfrm>
+            <a:off x="8211312" y="2487168"/>
+            <a:ext cx="475488" cy="41148"/>
+          </a:xfrm>
+          <a:prstGeom prst="rect">
+            <a:avLst/>
+          </a:prstGeom>
+          <a:solidFill>
+            <a:srgbClr val="D7A13A"/>
+          </a:solidFill>
+          <a:ln>
+            <a:noFill/>
+          </a:ln>
+        </p:spPr>
+        <p:style>
+          <a:lnRef idx="1">
+            <a:schemeClr val="accent1"/>
+          </a:lnRef>
+          <a:fillRef idx="3">
+            <a:schemeClr val="accent1"/>
+          </a:fillRef>
+          <a:effectRef idx="2">
+            <a:schemeClr val="accent1"/>
+          </a:effectRef>
+          <a:fontRef idx="minor">
+            <a:schemeClr val="lt1"/>
+          </a:fontRef>
+        </p:style>
+        <p:txBody>
+          <a:bodyPr rtlCol="0" anchor="ctr"/>
+          <a:lstStyle/>
+          <a:p>
+            <a:pPr algn="ctr"/>
           </a:p>
         </p:txBody>
       </p:sp>
@@ -10617,8 +10764,8 @@
         </p:nvSpPr>
         <p:spPr>
           <a:xfrm>
-            <a:off x="621792" y="6519672"/>
-            <a:ext cx="3200400" cy="164592"/>
+            <a:off x="8211312" y="2670048"/>
+            <a:ext cx="2487168" cy="219456"/>
           </a:xfrm>
           <a:prstGeom prst="rect">
             <a:avLst/>
@@ -10632,18 +10779,21 @@
           <a:lstStyle/>
           <a:p>
             <a:pPr algn="l">
-              <a:lnSpc>
-                <a:spcPct val="100000"/>
-              </a:lnSpc>
-            </a:pPr>
-            <a:r>
-              <a:rPr sz="750" b="1" i="0">
-                <a:solidFill>
-                  <a:srgbClr val="627080"/>
+              <a:spcBef>
+                <a:spcPts val="0"/>
+              </a:spcBef>
+              <a:spcAft>
+                <a:spcPts val="0"/>
+              </a:spcAft>
+            </a:pPr>
+            <a:r>
+              <a:rPr sz="1050" b="1" i="0">
+                <a:solidFill>
+                  <a:srgbClr val="102D4D"/>
                 </a:solidFill>
                 <a:latin typeface="Aptos"/>
               </a:rPr>
-              <a:t>MANIFEST  •  MADAGASCAR</a:t>
+              <a:t>ESTEEM</a:t>
             </a:r>
           </a:p>
         </p:txBody>
@@ -10656,8 +10806,8 @@
         </p:nvSpPr>
         <p:spPr>
           <a:xfrm>
-            <a:off x="11018520" y="6473952"/>
-            <a:ext cx="530352" cy="228600"/>
+            <a:off x="10744200" y="2651760"/>
+            <a:ext cx="384048" cy="228600"/>
           </a:xfrm>
           <a:prstGeom prst="rect">
             <a:avLst/>
@@ -10671,32 +10821,303 @@
           <a:lstStyle/>
           <a:p>
             <a:pPr algn="r">
+              <a:spcBef>
+                <a:spcPts val="0"/>
+              </a:spcBef>
+              <a:spcAft>
+                <a:spcPts val="0"/>
+              </a:spcAft>
+            </a:pPr>
+            <a:r>
+              <a:rPr sz="900" b="1" i="0">
+                <a:solidFill>
+                  <a:srgbClr val="D7A13A"/>
+                </a:solidFill>
+                <a:latin typeface="Aptos"/>
+              </a:rPr>
+              <a:t>04</a:t>
+            </a:r>
+          </a:p>
+        </p:txBody>
+      </p:sp>
+      <p:sp>
+        <p:nvSpPr>
+          <p:cNvPr id="33" name="TextBox 32"/>
+          <p:cNvSpPr txBox="1"/>
+          <p:nvPr/>
+        </p:nvSpPr>
+        <p:spPr>
+          <a:xfrm>
+            <a:off x="8211312" y="3017520"/>
+            <a:ext cx="2907792" cy="548640"/>
+          </a:xfrm>
+          <a:prstGeom prst="rect">
+            <a:avLst/>
+          </a:prstGeom>
+          <a:noFill/>
+        </p:spPr>
+        <p:txBody>
+          <a:bodyPr wrap="square" lIns="0" rIns="0" tIns="0" bIns="0">
+            <a:spAutoFit/>
+          </a:bodyPr>
+          <a:lstStyle/>
+          <a:p>
+            <a:pPr>
               <a:lnSpc>
-                <a:spcPct val="100000"/>
+                <a:spcPct val="105000"/>
               </a:lnSpc>
-            </a:pPr>
-            <a:r>
-              <a:rPr sz="800" b="1" i="0">
+              <a:spcBef>
+                <a:spcPts val="0"/>
+              </a:spcBef>
+              <a:spcAft>
+                <a:spcPts val="0"/>
+              </a:spcAft>
+            </a:pPr>
+            <a:r>
+              <a:rPr sz="1400">
                 <a:solidFill>
                   <a:srgbClr val="627080"/>
                 </a:solidFill>
                 <a:latin typeface="Aptos"/>
               </a:rPr>
-              <a:t>05</a:t>
+              <a:t>Knowing our God-given </a:t>
+            </a:r>
+            <a:r>
+              <a:rPr sz="1400" b="1">
+                <a:solidFill>
+                  <a:srgbClr val="102D4D"/>
+                </a:solidFill>
+                <a:latin typeface="Aptos"/>
+              </a:rPr>
+              <a:t>value and dignity.</a:t>
+            </a:r>
+          </a:p>
+        </p:txBody>
+      </p:sp>
+      <p:sp>
+        <p:nvSpPr>
+          <p:cNvPr id="34" name="Rounded Rectangle 33"/>
+          <p:cNvSpPr/>
+          <p:nvPr/>
+        </p:nvSpPr>
+        <p:spPr>
+          <a:xfrm>
+            <a:off x="4352544" y="4187952"/>
+            <a:ext cx="7013448" cy="1353312"/>
+          </a:xfrm>
+          <a:prstGeom prst="roundRect">
+            <a:avLst>
+              <a:gd name="adj" fmla="val 8000"/>
+            </a:avLst>
+          </a:prstGeom>
+          <a:solidFill>
+            <a:srgbClr val="D7A13A"/>
+          </a:solidFill>
+          <a:ln>
+            <a:noFill/>
+          </a:ln>
+        </p:spPr>
+        <p:style>
+          <a:lnRef idx="1">
+            <a:schemeClr val="accent1"/>
+          </a:lnRef>
+          <a:fillRef idx="3">
+            <a:schemeClr val="accent1"/>
+          </a:fillRef>
+          <a:effectRef idx="2">
+            <a:schemeClr val="accent1"/>
+          </a:effectRef>
+          <a:fontRef idx="minor">
+            <a:schemeClr val="lt1"/>
+          </a:fontRef>
+        </p:style>
+        <p:txBody>
+          <a:bodyPr rtlCol="0" anchor="ctr"/>
+          <a:lstStyle/>
+          <a:p>
+            <a:pPr algn="ctr"/>
+          </a:p>
+        </p:txBody>
+      </p:sp>
+      <p:sp>
+        <p:nvSpPr>
+          <p:cNvPr id="35" name="TextBox 34"/>
+          <p:cNvSpPr txBox="1"/>
+          <p:nvPr/>
+        </p:nvSpPr>
+        <p:spPr>
+          <a:xfrm>
+            <a:off x="4617720" y="4489704"/>
+            <a:ext cx="1316736" cy="310896"/>
+          </a:xfrm>
+          <a:prstGeom prst="rect">
+            <a:avLst/>
+          </a:prstGeom>
+          <a:noFill/>
+        </p:spPr>
+        <p:txBody>
+          <a:bodyPr wrap="square" lIns="0" rIns="0" tIns="0" bIns="0" anchor="ctr">
+            <a:spAutoFit/>
+          </a:bodyPr>
+          <a:lstStyle/>
+          <a:p>
+            <a:pPr algn="l">
+              <a:spcBef>
+                <a:spcPts val="0"/>
+              </a:spcBef>
+              <a:spcAft>
+                <a:spcPts val="0"/>
+              </a:spcAft>
+            </a:pPr>
+            <a:r>
+              <a:rPr sz="1550" b="1" i="0">
+                <a:solidFill>
+                  <a:srgbClr val="071A2D"/>
+                </a:solidFill>
+                <a:latin typeface="Aptos"/>
+              </a:rPr>
+              <a:t>MANIFEST</a:t>
+            </a:r>
+          </a:p>
+        </p:txBody>
+      </p:sp>
+      <p:sp>
+        <p:nvSpPr>
+          <p:cNvPr id="36" name="Rectangle 35"/>
+          <p:cNvSpPr/>
+          <p:nvPr/>
+        </p:nvSpPr>
+        <p:spPr>
+          <a:xfrm>
+            <a:off x="6117336" y="4471416"/>
+            <a:ext cx="14630" cy="722376"/>
+          </a:xfrm>
+          <a:prstGeom prst="rect">
+            <a:avLst/>
+          </a:prstGeom>
+          <a:solidFill>
+            <a:srgbClr val="A8751F"/>
+          </a:solidFill>
+          <a:ln>
+            <a:noFill/>
+          </a:ln>
+        </p:spPr>
+        <p:style>
+          <a:lnRef idx="1">
+            <a:schemeClr val="accent1"/>
+          </a:lnRef>
+          <a:fillRef idx="3">
+            <a:schemeClr val="accent1"/>
+          </a:fillRef>
+          <a:effectRef idx="2">
+            <a:schemeClr val="accent1"/>
+          </a:effectRef>
+          <a:fontRef idx="minor">
+            <a:schemeClr val="lt1"/>
+          </a:fontRef>
+        </p:style>
+        <p:txBody>
+          <a:bodyPr rtlCol="0" anchor="ctr"/>
+          <a:lstStyle/>
+          <a:p>
+            <a:pPr algn="ctr"/>
+          </a:p>
+        </p:txBody>
+      </p:sp>
+      <p:sp>
+        <p:nvSpPr>
+          <p:cNvPr id="37" name="TextBox 36"/>
+          <p:cNvSpPr txBox="1"/>
+          <p:nvPr/>
+        </p:nvSpPr>
+        <p:spPr>
+          <a:xfrm>
+            <a:off x="6409944" y="4361688"/>
+            <a:ext cx="4608576" cy="932688"/>
+          </a:xfrm>
+          <a:prstGeom prst="rect">
+            <a:avLst/>
+          </a:prstGeom>
+          <a:noFill/>
+        </p:spPr>
+        <p:txBody>
+          <a:bodyPr wrap="square" lIns="0" rIns="0" tIns="0" bIns="0" anchor="ctr">
+            <a:spAutoFit/>
+          </a:bodyPr>
+          <a:lstStyle/>
+          <a:p>
+            <a:pPr algn="l">
+              <a:spcBef>
+                <a:spcPts val="0"/>
+              </a:spcBef>
+              <a:spcAft>
+                <a:spcPts val="0"/>
+              </a:spcAft>
+            </a:pPr>
+            <a:r>
+              <a:rPr sz="1350" b="1" i="0">
+                <a:solidFill>
+                  <a:srgbClr val="071A2D"/>
+                </a:solidFill>
+                <a:latin typeface="Aptos"/>
+              </a:rPr>
+              <a:t>People becoming who God created them to be through the transforming power of the Gospel.</a:t>
+            </a:r>
+          </a:p>
+        </p:txBody>
+      </p:sp>
+      <p:sp>
+        <p:nvSpPr>
+          <p:cNvPr id="38" name="TextBox 37"/>
+          <p:cNvSpPr txBox="1"/>
+          <p:nvPr/>
+        </p:nvSpPr>
+        <p:spPr>
+          <a:xfrm>
+            <a:off x="4370832" y="5760720"/>
+            <a:ext cx="6903720" cy="310896"/>
+          </a:xfrm>
+          <a:prstGeom prst="rect">
+            <a:avLst/>
+          </a:prstGeom>
+          <a:noFill/>
+        </p:spPr>
+        <p:txBody>
+          <a:bodyPr wrap="square" lIns="0" rIns="0" tIns="0" bIns="0" anchor="ctr">
+            <a:spAutoFit/>
+          </a:bodyPr>
+          <a:lstStyle/>
+          <a:p>
+            <a:pPr algn="ctr">
+              <a:spcBef>
+                <a:spcPts val="0"/>
+              </a:spcBef>
+              <a:spcAft>
+                <a:spcPts val="0"/>
+              </a:spcAft>
+            </a:pPr>
+            <a:r>
+              <a:rPr sz="1120" b="0" i="1">
+                <a:solidFill>
+                  <a:srgbClr val="D8E1E8"/>
+                </a:solidFill>
+                <a:latin typeface="Aptos"/>
+              </a:rPr>
+              <a:t>Every programme begins with the person—not the problem.</a:t>
             </a:r>
           </a:p>
         </p:txBody>
       </p:sp>
       <p:pic>
         <p:nvPicPr>
-          <p:cNvPr id="33" name="Picture 32" descr="logo-watermark.png"/>
+          <p:cNvPr id="39" name="Picture 38" descr="image.png"/>
           <p:cNvPicPr>
             <a:picLocks noChangeAspect="1"/>
           </p:cNvPicPr>
           <p:nvPr/>
         </p:nvPicPr>
         <p:blipFill>
-          <a:blip r:embed="rId3"/>
+          <a:blip r:embed="rId5"/>
           <a:stretch>
             <a:fillRect/>
           </a:stretch>
@@ -10711,6 +11132,90 @@
           </a:prstGeom>
         </p:spPr>
       </p:pic>
+      <p:sp>
+        <p:nvSpPr>
+          <p:cNvPr id="40" name="TextBox 39"/>
+          <p:cNvSpPr txBox="1"/>
+          <p:nvPr/>
+        </p:nvSpPr>
+        <p:spPr>
+          <a:xfrm>
+            <a:off x="621792" y="6519672"/>
+            <a:ext cx="3200400" cy="164592"/>
+          </a:xfrm>
+          <a:prstGeom prst="rect">
+            <a:avLst/>
+          </a:prstGeom>
+          <a:noFill/>
+        </p:spPr>
+        <p:txBody>
+          <a:bodyPr wrap="square" lIns="0" rIns="0" tIns="0" bIns="0" anchor="t">
+            <a:spAutoFit/>
+          </a:bodyPr>
+          <a:lstStyle/>
+          <a:p>
+            <a:pPr algn="l">
+              <a:spcBef>
+                <a:spcPts val="0"/>
+              </a:spcBef>
+              <a:spcAft>
+                <a:spcPts val="0"/>
+              </a:spcAft>
+            </a:pPr>
+            <a:r>
+              <a:rPr sz="750" b="1" i="0">
+                <a:solidFill>
+                  <a:srgbClr val="D8E1E8"/>
+                </a:solidFill>
+                <a:latin typeface="Aptos"/>
+              </a:rPr>
+              <a:t>MANIFEST  •  MADAGASCAR</a:t>
+            </a:r>
+          </a:p>
+        </p:txBody>
+      </p:sp>
+      <p:sp>
+        <p:nvSpPr>
+          <p:cNvPr id="41" name="TextBox 40"/>
+          <p:cNvSpPr txBox="1"/>
+          <p:nvPr/>
+        </p:nvSpPr>
+        <p:spPr>
+          <a:xfrm>
+            <a:off x="11018520" y="6473952"/>
+            <a:ext cx="530352" cy="228600"/>
+          </a:xfrm>
+          <a:prstGeom prst="rect">
+            <a:avLst/>
+          </a:prstGeom>
+          <a:noFill/>
+        </p:spPr>
+        <p:txBody>
+          <a:bodyPr wrap="square" lIns="0" rIns="0" tIns="0" bIns="0" anchor="t">
+            <a:spAutoFit/>
+          </a:bodyPr>
+          <a:lstStyle/>
+          <a:p>
+            <a:pPr algn="r">
+              <a:spcBef>
+                <a:spcPts val="0"/>
+              </a:spcBef>
+              <a:spcAft>
+                <a:spcPts val="0"/>
+              </a:spcAft>
+            </a:pPr>
+            <a:r>
+              <a:rPr sz="800" b="1" i="0">
+                <a:solidFill>
+                  <a:srgbClr val="D8E1E8"/>
+                </a:solidFill>
+                <a:latin typeface="Aptos"/>
+              </a:rPr>
+              <a:t>05</a:t>
+            </a:r>
+          </a:p>
+        </p:txBody>
+      </p:sp>
     </p:spTree>
   </p:cSld>
   <p:clrMapOvr>

</xml_diff>